<commit_message>
Muda grao da fato pra mensal, resolve de-para de vacina/dose/estrategia, corrige join de municipio e adiciona apresentacao tecnica
</commit_message>
<xml_diff>
--- a/apresentacao/apresentacao-tecnica-pni.pptx
+++ b/apresentacao/apresentacao-tecnica-pni.pptx
@@ -9691,7 +9691,7 @@
         <p:spPr>
           <a:xfrm>
             <a:off x="457200" y="2743200"/>
-            <a:ext cx="1554480" cy="1737360"/>
+            <a:ext cx="1463040" cy="1737360"/>
           </a:xfrm>
           <a:prstGeom prst="rect">
             <a:avLst/>
@@ -9711,7 +9711,7 @@
         <p:spPr>
           <a:xfrm>
             <a:off x="457200" y="2971800"/>
-            <a:ext cx="1554480" cy="365760"/>
+            <a:ext cx="1463040" cy="365760"/>
           </a:xfrm>
           <a:prstGeom prst="rect">
             <a:avLst/>
@@ -9750,7 +9750,7 @@
         <p:spPr>
           <a:xfrm>
             <a:off x="457200" y="3383280"/>
-            <a:ext cx="1554480" cy="914400"/>
+            <a:ext cx="1463040" cy="914400"/>
           </a:xfrm>
           <a:prstGeom prst="rect">
             <a:avLst/>
@@ -9805,8 +9805,8 @@
         </p:nvSpPr>
         <p:spPr>
           <a:xfrm>
-            <a:off x="2039112" y="3493008"/>
-            <a:ext cx="265176" cy="237744"/>
+            <a:off x="1947672" y="3493008"/>
+            <a:ext cx="219456" cy="237744"/>
           </a:xfrm>
           <a:prstGeom prst="rightArrow">
             <a:avLst/>
@@ -9825,8 +9825,8 @@
         </p:nvSpPr>
         <p:spPr>
           <a:xfrm>
-            <a:off x="2331720" y="2743200"/>
-            <a:ext cx="1737360" cy="1737360"/>
+            <a:off x="2194560" y="2743200"/>
+            <a:ext cx="1645920" cy="1737360"/>
           </a:xfrm>
           <a:prstGeom prst="rect">
             <a:avLst/>
@@ -9845,8 +9845,8 @@
         </p:nvSpPr>
         <p:spPr>
           <a:xfrm>
-            <a:off x="2331720" y="2971800"/>
-            <a:ext cx="1737360" cy="365760"/>
+            <a:off x="2194560" y="2971800"/>
+            <a:ext cx="1645920" cy="365760"/>
           </a:xfrm>
           <a:prstGeom prst="rect">
             <a:avLst/>
@@ -9884,8 +9884,8 @@
         </p:nvSpPr>
         <p:spPr>
           <a:xfrm>
-            <a:off x="2331720" y="3383280"/>
-            <a:ext cx="1737360" cy="914400"/>
+            <a:off x="2194560" y="3383280"/>
+            <a:ext cx="1645920" cy="914400"/>
           </a:xfrm>
           <a:prstGeom prst="rect">
             <a:avLst/>
@@ -9940,8 +9940,8 @@
         </p:nvSpPr>
         <p:spPr>
           <a:xfrm>
-            <a:off x="4096512" y="3493008"/>
-            <a:ext cx="265176" cy="237744"/>
+            <a:off x="3867912" y="3493008"/>
+            <a:ext cx="219456" cy="237744"/>
           </a:xfrm>
           <a:prstGeom prst="rightArrow">
             <a:avLst/>
@@ -9960,8 +9960,8 @@
         </p:nvSpPr>
         <p:spPr>
           <a:xfrm>
-            <a:off x="4389120" y="2743200"/>
-            <a:ext cx="1737360" cy="1737360"/>
+            <a:off x="4114800" y="2743200"/>
+            <a:ext cx="1645920" cy="1737360"/>
           </a:xfrm>
           <a:prstGeom prst="rect">
             <a:avLst/>
@@ -9980,8 +9980,8 @@
         </p:nvSpPr>
         <p:spPr>
           <a:xfrm>
-            <a:off x="4389120" y="2971800"/>
-            <a:ext cx="1737360" cy="365760"/>
+            <a:off x="4114800" y="2971800"/>
+            <a:ext cx="1645920" cy="365760"/>
           </a:xfrm>
           <a:prstGeom prst="rect">
             <a:avLst/>
@@ -10019,8 +10019,8 @@
         </p:nvSpPr>
         <p:spPr>
           <a:xfrm>
-            <a:off x="4389120" y="3383280"/>
-            <a:ext cx="1737360" cy="914400"/>
+            <a:off x="4114800" y="3383280"/>
+            <a:ext cx="1645920" cy="914400"/>
           </a:xfrm>
           <a:prstGeom prst="rect">
             <a:avLst/>
@@ -10075,8 +10075,8 @@
         </p:nvSpPr>
         <p:spPr>
           <a:xfrm>
-            <a:off x="6153912" y="3493008"/>
-            <a:ext cx="265176" cy="237744"/>
+            <a:off x="5788152" y="3493008"/>
+            <a:ext cx="219456" cy="237744"/>
           </a:xfrm>
           <a:prstGeom prst="rightArrow">
             <a:avLst/>
@@ -10095,8 +10095,8 @@
         </p:nvSpPr>
         <p:spPr>
           <a:xfrm>
-            <a:off x="6446520" y="2743200"/>
-            <a:ext cx="1920240" cy="1737360"/>
+            <a:off x="6035040" y="2743200"/>
+            <a:ext cx="1828800" cy="1737360"/>
           </a:xfrm>
           <a:prstGeom prst="rect">
             <a:avLst/>
@@ -10115,8 +10115,8 @@
         </p:nvSpPr>
         <p:spPr>
           <a:xfrm>
-            <a:off x="6446520" y="2971800"/>
-            <a:ext cx="1920240" cy="365760"/>
+            <a:off x="6035040" y="2971800"/>
+            <a:ext cx="1828800" cy="365760"/>
           </a:xfrm>
           <a:prstGeom prst="rect">
             <a:avLst/>
@@ -10154,8 +10154,8 @@
         </p:nvSpPr>
         <p:spPr>
           <a:xfrm>
-            <a:off x="6446520" y="3383280"/>
-            <a:ext cx="1920240" cy="914400"/>
+            <a:off x="6035040" y="3383280"/>
+            <a:ext cx="1828800" cy="914400"/>
           </a:xfrm>
           <a:prstGeom prst="rect">
             <a:avLst/>
@@ -10210,8 +10210,8 @@
         </p:nvSpPr>
         <p:spPr>
           <a:xfrm>
-            <a:off x="8394192" y="3493008"/>
-            <a:ext cx="265176" cy="237744"/>
+            <a:off x="7891272" y="3493008"/>
+            <a:ext cx="219456" cy="237744"/>
           </a:xfrm>
           <a:prstGeom prst="rightArrow">
             <a:avLst/>
@@ -10230,8 +10230,8 @@
         </p:nvSpPr>
         <p:spPr>
           <a:xfrm>
-            <a:off x="8686800" y="2743200"/>
-            <a:ext cx="1737360" cy="1737360"/>
+            <a:off x="8138160" y="2743200"/>
+            <a:ext cx="1645920" cy="1737360"/>
           </a:xfrm>
           <a:prstGeom prst="rect">
             <a:avLst/>
@@ -10250,8 +10250,8 @@
         </p:nvSpPr>
         <p:spPr>
           <a:xfrm>
-            <a:off x="8686800" y="2971800"/>
-            <a:ext cx="1737360" cy="365760"/>
+            <a:off x="8138160" y="2971800"/>
+            <a:ext cx="1645920" cy="365760"/>
           </a:xfrm>
           <a:prstGeom prst="rect">
             <a:avLst/>
@@ -10289,8 +10289,8 @@
         </p:nvSpPr>
         <p:spPr>
           <a:xfrm>
-            <a:off x="8686800" y="3383280"/>
-            <a:ext cx="1737360" cy="914400"/>
+            <a:off x="8138160" y="3383280"/>
+            <a:ext cx="1645920" cy="914400"/>
           </a:xfrm>
           <a:prstGeom prst="rect">
             <a:avLst/>
@@ -10345,8 +10345,8 @@
         </p:nvSpPr>
         <p:spPr>
           <a:xfrm>
-            <a:off x="10451592" y="3493008"/>
-            <a:ext cx="265176" cy="237744"/>
+            <a:off x="9811512" y="3493008"/>
+            <a:ext cx="219456" cy="237744"/>
           </a:xfrm>
           <a:prstGeom prst="rightArrow">
             <a:avLst/>
@@ -10365,8 +10365,8 @@
         </p:nvSpPr>
         <p:spPr>
           <a:xfrm>
-            <a:off x="10744200" y="2743200"/>
-            <a:ext cx="1737360" cy="1737360"/>
+            <a:off x="10058400" y="2743200"/>
+            <a:ext cx="1645920" cy="1737360"/>
           </a:xfrm>
           <a:prstGeom prst="rect">
             <a:avLst/>
@@ -10385,8 +10385,8 @@
         </p:nvSpPr>
         <p:spPr>
           <a:xfrm>
-            <a:off x="10744200" y="2971800"/>
-            <a:ext cx="1737360" cy="365760"/>
+            <a:off x="10058400" y="2971800"/>
+            <a:ext cx="1645920" cy="365760"/>
           </a:xfrm>
           <a:prstGeom prst="rect">
             <a:avLst/>
@@ -10424,8 +10424,8 @@
         </p:nvSpPr>
         <p:spPr>
           <a:xfrm>
-            <a:off x="10744200" y="3383280"/>
-            <a:ext cx="1737360" cy="914400"/>
+            <a:off x="10058400" y="3383280"/>
+            <a:ext cx="1645920" cy="914400"/>
           </a:xfrm>
           <a:prstGeom prst="rect">
             <a:avLst/>
@@ -10480,8 +10480,8 @@
         </p:nvSpPr>
         <p:spPr>
           <a:xfrm>
-            <a:off x="2148840" y="4709160"/>
-            <a:ext cx="6400800" cy="320040"/>
+            <a:off x="4114800" y="4709160"/>
+            <a:ext cx="5669280" cy="320040"/>
           </a:xfrm>
           <a:prstGeom prst="rect">
             <a:avLst/>

</xml_diff>

<commit_message>
Corrige largura das caixas do diagrama (Power BI cortando)
</commit_message>
<xml_diff>
--- a/apresentacao/apresentacao-tecnica-pni.pptx
+++ b/apresentacao/apresentacao-tecnica-pni.pptx
@@ -4,6 +4,9 @@
   <p:sldMasterIdLst>
     <p:sldMasterId id="2147483648" r:id="rId1"/>
   </p:sldMasterIdLst>
+  <p:notesMasterIdLst>
+    <p:notesMasterId r:id="rId19"/>
+  </p:notesMasterIdLst>
   <p:sldIdLst>
     <p:sldId id="256" r:id="rId2"/>
     <p:sldId id="257" r:id="rId3"/>
@@ -23,9 +26,6 @@
     <p:sldId id="271" r:id="rId17"/>
     <p:sldId id="272" r:id="rId18"/>
   </p:sldIdLst>
-  <p:notesMasterIdLst>
-    <p:notesMasterId r:id="rId19"/>
-  </p:notesMasterIdLst>
   <p:sldSz cx="12192000" cy="6858000"/>
   <p:notesSz cx="6858000" cy="12192000"/>
   <p:defaultTextStyle>
@@ -120,13 +120,20 @@
       </a:defRPr>
     </a:lvl9pPr>
   </p:defaultTextStyle>
+  <p:extLst>
+    <p:ext uri="{EFAFB233-063F-42B5-8137-9DF3F51BA10A}">
+      <p15:sldGuideLst xmlns:p15="http://schemas.microsoft.com/office/powerpoint/2012/main"/>
+    </p:ext>
+  </p:extLst>
 </p:presentation>
 </file>
 
 <file path=ppt/charts/chart1.xml><?xml version="1.0" encoding="utf-8"?>
-<c:chartSpace xmlns:c="http://schemas.openxmlformats.org/drawingml/2006/chart" xmlns:a="http://schemas.openxmlformats.org/drawingml/2006/main" xmlns:r="http://schemas.openxmlformats.org/officeDocument/2006/relationships">
+<c:chartSpace xmlns:c="http://schemas.openxmlformats.org/drawingml/2006/chart" xmlns:a="http://schemas.openxmlformats.org/drawingml/2006/main" xmlns:r="http://schemas.openxmlformats.org/officeDocument/2006/relationships" xmlns:c16r2="http://schemas.microsoft.com/office/drawing/2015/06/chart">
   <c:date1904 val="0"/>
+  <c:lang val="pt-BR"/>
   <c:roundedCorners val="1"/>
+  <c:style val="2"/>
   <c:chart>
     <c:title>
       <c:tx>
@@ -143,7 +150,7 @@
               </a:defRPr>
             </a:pPr>
             <a:r>
-              <a:rPr sz="1300" b="0" i="0" u="none" strike="noStrike">
+              <a:rPr lang="pt-BR" sz="1300" b="0" i="0" u="none" strike="noStrike">
                 <a:solidFill>
                   <a:srgbClr val="0B3D59"/>
                 </a:solidFill>
@@ -154,7 +161,6 @@
           </a:p>
         </c:rich>
       </c:tx>
-      <c:layout/>
       <c:overlay val="0"/>
     </c:title>
     <c:autoTitleDeleted val="0"/>
@@ -187,18 +193,26 @@
           <c:invertIfNegative val="0"/>
           <c:dLbls>
             <c:numFmt formatCode="#,##0" sourceLinked="0"/>
+            <c:spPr>
+              <a:noFill/>
+              <a:ln>
+                <a:noFill/>
+              </a:ln>
+              <a:effectLst/>
+            </c:spPr>
             <c:txPr>
               <a:bodyPr/>
               <a:lstStyle/>
               <a:p>
                 <a:pPr>
-                  <a:defRPr b="0" i="0" strike="noStrike" sz="1000" u="none">
+                  <a:defRPr sz="1000" b="0" i="0" u="none" strike="noStrike">
                     <a:solidFill>
                       <a:srgbClr val="5B6B75"/>
                     </a:solidFill>
                     <a:latin typeface="Arial"/>
                   </a:defRPr>
                 </a:pPr>
+                <a:endParaRPr lang="pt-BR"/>
               </a:p>
             </c:txPr>
             <c:showLegendKey val="0"/>
@@ -208,37 +222,40 @@
             <c:showPercent val="0"/>
             <c:showBubbleSize val="0"/>
             <c:showLeaderLines val="0"/>
+            <c:extLst>
+              <c:ext xmlns:c15="http://schemas.microsoft.com/office/drawing/2012/chart" uri="{CE6537A1-D6FC-4f65-9D91-7224C49458BB}">
+                <c15:showLeaderLines val="0"/>
+              </c:ext>
+            </c:extLst>
           </c:dLbls>
           <c:cat>
-            <c:multiLvlStrRef>
+            <c:strRef>
               <c:f>Sheet1!$A$2:$A$8</c:f>
-              <c:multiLvlStrCache>
+              <c:strCache>
                 <c:ptCount val="7"/>
-                <c:lvl>
-                  <c:pt idx="0">
-                    <c:v>Jan</c:v>
-                  </c:pt>
-                  <c:pt idx="1">
-                    <c:v>Fev</c:v>
-                  </c:pt>
-                  <c:pt idx="2">
-                    <c:v>Mar</c:v>
-                  </c:pt>
-                  <c:pt idx="3">
-                    <c:v>Abr</c:v>
-                  </c:pt>
-                  <c:pt idx="4">
-                    <c:v>Mai</c:v>
-                  </c:pt>
-                  <c:pt idx="5">
-                    <c:v>Jun</c:v>
-                  </c:pt>
-                  <c:pt idx="6">
-                    <c:v>Jul</c:v>
-                  </c:pt>
-                </c:lvl>
-              </c:multiLvlStrCache>
-            </c:multiLvlStrRef>
+                <c:pt idx="0">
+                  <c:v>Jan</c:v>
+                </c:pt>
+                <c:pt idx="1">
+                  <c:v>Fev</c:v>
+                </c:pt>
+                <c:pt idx="2">
+                  <c:v>Mar</c:v>
+                </c:pt>
+                <c:pt idx="3">
+                  <c:v>Abr</c:v>
+                </c:pt>
+                <c:pt idx="4">
+                  <c:v>Mai</c:v>
+                </c:pt>
+                <c:pt idx="5">
+                  <c:v>Jun</c:v>
+                </c:pt>
+                <c:pt idx="6">
+                  <c:v>Jul</c:v>
+                </c:pt>
+              </c:strCache>
+            </c:strRef>
           </c:cat>
           <c:val>
             <c:numRef>
@@ -253,7 +270,7 @@
                   <c:v>5.4</c:v>
                 </c:pt>
                 <c:pt idx="2">
-                  <c:v>9.7</c:v>
+                  <c:v>9.6999999999999993</c:v>
                 </c:pt>
                 <c:pt idx="3">
                   <c:v>16.7</c:v>
@@ -270,36 +287,23 @@
               </c:numCache>
             </c:numRef>
           </c:val>
+          <c:extLst>
+            <c:ext xmlns:c16="http://schemas.microsoft.com/office/drawing/2014/chart" uri="{C3380CC4-5D6E-409C-BE32-E72D297353CC}">
+              <c16:uniqueId val="{00000000-04E1-4CD7-B57F-F0D9661A2795}"/>
+            </c:ext>
+          </c:extLst>
         </c:ser>
         <c:dLbls>
-          <c:numFmt formatCode="#,##0" sourceLinked="0"/>
-          <c:txPr>
-            <a:bodyPr/>
-            <a:lstStyle/>
-            <a:p>
-              <a:pPr>
-                <a:defRPr b="0" i="0" strike="noStrike" sz="1000" u="none">
-                  <a:solidFill>
-                    <a:srgbClr val="5B6B75"/>
-                  </a:solidFill>
-                  <a:latin typeface="Arial"/>
-                </a:defRPr>
-              </a:pPr>
-            </a:p>
-          </c:txPr>
           <c:showLegendKey val="0"/>
           <c:showVal val="1"/>
           <c:showCatName val="0"/>
           <c:showSerName val="0"/>
           <c:showPercent val="0"/>
           <c:showBubbleSize val="0"/>
-          <c:showLeaderLines val="0"/>
         </c:dLbls>
         <c:gapWidth val="35"/>
-        <c:overlap val="0"/>
         <c:axId val="2094734554"/>
         <c:axId val="2094734552"/>
-        <c:axId val="2094734556"/>
       </c:barChart>
       <c:catAx>
         <c:axId val="2094734554"/>
@@ -340,6 +344,7 @@
         <c:crosses val="autoZero"/>
         <c:auto val="1"/>
         <c:lblAlgn val="ctr"/>
+        <c:lblOffset val="100"/>
         <c:noMultiLvlLbl val="1"/>
       </c:catAx>
       <c:valAx>
@@ -402,6 +407,7 @@
     </c:plotArea>
     <c:plotVisOnly val="1"/>
     <c:dispBlanksAs val="span"/>
+    <c:showDLblsOverMax val="1"/>
   </c:chart>
   <c:spPr>
     <a:noFill/>
@@ -438,234 +444,10 @@
           <a:chExt cx="0" cy="0"/>
         </a:xfrm>
       </p:grpSpPr>
-      <p:sp>
-        <p:nvSpPr>
-          <p:cNvPr id="2" name="Header Placeholder 1"/>
-          <p:cNvSpPr>
-            <a:spLocks noGrp="1"/>
-          </p:cNvSpPr>
-          <p:nvPr>
-            <p:ph type="hdr" sz="quarter"/>
-          </p:nvPr>
-        </p:nvSpPr>
-        <p:spPr>
-          <a:xfrm>
-            <a:off x="0" y="0"/>
-            <a:ext cx="2971800" cy="458788"/>
-          </a:xfrm>
-          <a:prstGeom prst="rect">
-            <a:avLst/>
-          </a:prstGeom>
-        </p:spPr>
-        <p:txBody>
-          <a:bodyPr vert="horz" lIns="91440" tIns="45720" rIns="91440" bIns="45720" rtlCol="0"/>
-          <a:lstStyle>
-            <a:lvl1pPr algn="l">
-              <a:defRPr sz="1200"/>
-            </a:lvl1pPr>
-          </a:lstStyle>
-          <a:p>
-            <a:endParaRPr lang="en-US"/>
-          </a:p>
-        </p:txBody>
-      </p:sp>
-      <p:sp>
-        <p:nvSpPr>
-          <p:cNvPr id="3" name="Date Placeholder 2"/>
-          <p:cNvSpPr>
-            <a:spLocks noGrp="1"/>
-          </p:cNvSpPr>
-          <p:nvPr>
-            <p:ph type="dt" idx="1"/>
-          </p:nvPr>
-        </p:nvSpPr>
-        <p:spPr>
-          <a:xfrm>
-            <a:off x="3884613" y="0"/>
-            <a:ext cx="2971800" cy="458788"/>
-          </a:xfrm>
-          <a:prstGeom prst="rect">
-            <a:avLst/>
-          </a:prstGeom>
-        </p:spPr>
-        <p:txBody>
-          <a:bodyPr vert="horz" lIns="91440" tIns="45720" rIns="91440" bIns="45720" rtlCol="0"/>
-          <a:lstStyle>
-            <a:lvl1pPr algn="r">
-              <a:defRPr sz="1200"/>
-            </a:lvl1pPr>
-          </a:lstStyle>
-          <a:p>
-            <a:fld id="{5282F153-3F37-0F45-9E97-73ACFA13230C}" type="datetimeFigureOut">
-              <a:rPr lang="en-US"/>
-              <a:t>7/23/19</a:t>
-            </a:fld>
-            <a:endParaRPr lang="en-US"/>
-          </a:p>
-        </p:txBody>
-      </p:sp>
-      <p:sp>
-        <p:nvSpPr>
-          <p:cNvPr id="4" name="Slide Image Placeholder 3"/>
-          <p:cNvSpPr>
-            <a:spLocks noGrp="1" noRot="1" noChangeAspect="1"/>
-          </p:cNvSpPr>
-          <p:nvPr>
-            <p:ph type="sldImg" idx="2"/>
-          </p:nvPr>
-        </p:nvSpPr>
-        <p:spPr>
-          <a:xfrm>
-            <a:off x="685800" y="1143000"/>
-            <a:ext cx="5486400" cy="3086100"/>
-          </a:xfrm>
-          <a:prstGeom prst="rect">
-            <a:avLst/>
-          </a:prstGeom>
-          <a:noFill/>
-          <a:ln w="12700">
-            <a:solidFill>
-              <a:prstClr val="black"/>
-            </a:solidFill>
-          </a:ln>
-        </p:spPr>
-        <p:txBody>
-          <a:bodyPr vert="horz" lIns="91440" tIns="45720" rIns="91440" bIns="45720" rtlCol="0" anchor="ctr"/>
-          <a:lstStyle/>
-          <a:p>
-            <a:endParaRPr lang="en-US"/>
-          </a:p>
-        </p:txBody>
-      </p:sp>
-      <p:sp>
-        <p:nvSpPr>
-          <p:cNvPr id="5" name="Notes Placeholder 4"/>
-          <p:cNvSpPr>
-            <a:spLocks noGrp="1"/>
-          </p:cNvSpPr>
-          <p:nvPr>
-            <p:ph type="body" sz="quarter" idx="3"/>
-          </p:nvPr>
-        </p:nvSpPr>
-        <p:spPr>
-          <a:xfrm>
-            <a:off x="685800" y="4400550"/>
-            <a:ext cx="5486400" cy="3600450"/>
-          </a:xfrm>
-          <a:prstGeom prst="rect">
-            <a:avLst/>
-          </a:prstGeom>
-        </p:spPr>
-        <p:txBody>
-          <a:bodyPr vert="horz" lIns="91440" tIns="45720" rIns="91440" bIns="45720" rtlCol="0"/>
-          <a:lstStyle/>
-          <a:p>
-            <a:pPr lvl="0"/>
-            <a:r>
-              <a:rPr lang="en-US"/>
-              <a:t>Click to edit Master text styles</a:t>
-            </a:r>
-          </a:p>
-          <a:p>
-            <a:pPr lvl="1"/>
-            <a:r>
-              <a:rPr lang="en-US"/>
-              <a:t>Second level</a:t>
-            </a:r>
-          </a:p>
-          <a:p>
-            <a:pPr lvl="2"/>
-            <a:r>
-              <a:rPr lang="en-US"/>
-              <a:t>Third level</a:t>
-            </a:r>
-          </a:p>
-          <a:p>
-            <a:pPr lvl="3"/>
-            <a:r>
-              <a:rPr lang="en-US"/>
-              <a:t>Fourth level</a:t>
-            </a:r>
-          </a:p>
-          <a:p>
-            <a:pPr lvl="4"/>
-            <a:r>
-              <a:rPr lang="en-US"/>
-              <a:t>Fifth level</a:t>
-            </a:r>
-          </a:p>
-        </p:txBody>
-      </p:sp>
-      <p:sp>
-        <p:nvSpPr>
-          <p:cNvPr id="6" name="Footer Placeholder 5"/>
-          <p:cNvSpPr>
-            <a:spLocks noGrp="1"/>
-          </p:cNvSpPr>
-          <p:nvPr>
-            <p:ph type="ftr" sz="quarter" idx="4"/>
-          </p:nvPr>
-        </p:nvSpPr>
-        <p:spPr>
-          <a:xfrm>
-            <a:off x="0" y="8685213"/>
-            <a:ext cx="2971800" cy="458787"/>
-          </a:xfrm>
-          <a:prstGeom prst="rect">
-            <a:avLst/>
-          </a:prstGeom>
-        </p:spPr>
-        <p:txBody>
-          <a:bodyPr vert="horz" lIns="91440" tIns="45720" rIns="91440" bIns="45720" rtlCol="0" anchor="b"/>
-          <a:lstStyle>
-            <a:lvl1pPr algn="l">
-              <a:defRPr sz="1200"/>
-            </a:lvl1pPr>
-          </a:lstStyle>
-          <a:p>
-            <a:endParaRPr lang="en-US"/>
-          </a:p>
-        </p:txBody>
-      </p:sp>
-      <p:sp>
-        <p:nvSpPr>
-          <p:cNvPr id="7" name="Slide Number Placeholder 6"/>
-          <p:cNvSpPr>
-            <a:spLocks noGrp="1"/>
-          </p:cNvSpPr>
-          <p:nvPr>
-            <p:ph type="sldNum" sz="quarter" idx="5"/>
-          </p:nvPr>
-        </p:nvSpPr>
-        <p:spPr>
-          <a:xfrm>
-            <a:off x="3884613" y="8685213"/>
-            <a:ext cx="2971800" cy="458787"/>
-          </a:xfrm>
-          <a:prstGeom prst="rect">
-            <a:avLst/>
-          </a:prstGeom>
-        </p:spPr>
-        <p:txBody>
-          <a:bodyPr vert="horz" lIns="91440" tIns="45720" rIns="91440" bIns="45720" rtlCol="0" anchor="b"/>
-          <a:lstStyle>
-            <a:lvl1pPr algn="r">
-              <a:defRPr sz="1200"/>
-            </a:lvl1pPr>
-          </a:lstStyle>
-          <a:p>
-            <a:fld id="{CE5E9CC1-C706-0F49-92D6-E571CC5EEA8F}" type="slidenum">
-              <a:rPr lang="en-US"/>
-              <a:t>‹#›</a:t>
-            </a:fld>
-            <a:endParaRPr lang="en-US"/>
-          </a:p>
-        </p:txBody>
-      </p:sp>
     </p:spTree>
     <p:extLst>
       <p:ext uri="{BB962C8B-B14F-4D97-AF65-F5344CB8AC3E}">
-        <p14:creationId xmlns:p14="http://schemas.microsoft.com/office/powerpoint/2010/main" val="1024086991"/>
+        <p14:creationId xmlns:p14="http://schemas.microsoft.com/office/powerpoint/2010/main" val="396480763"/>
       </p:ext>
     </p:extLst>
   </p:cSld>
@@ -809,10 +591,6 @@
           <a:bodyPr/>
           <a:lstStyle/>
           <a:p>
-            <a:r>
-              <a:rPr lang="en-US" dirty="0"/>
-              <a:t/>
-            </a:r>
             <a:endParaRPr lang="en-US" dirty="0"/>
           </a:p>
         </p:txBody>
@@ -897,10 +675,6 @@
           <a:bodyPr/>
           <a:lstStyle/>
           <a:p>
-            <a:r>
-              <a:rPr lang="en-US" dirty="0"/>
-              <a:t/>
-            </a:r>
             <a:endParaRPr lang="en-US" dirty="0"/>
           </a:p>
         </p:txBody>
@@ -985,10 +759,6 @@
           <a:bodyPr/>
           <a:lstStyle/>
           <a:p>
-            <a:r>
-              <a:rPr lang="en-US" dirty="0"/>
-              <a:t/>
-            </a:r>
             <a:endParaRPr lang="en-US" dirty="0"/>
           </a:p>
         </p:txBody>
@@ -1073,10 +843,6 @@
           <a:bodyPr/>
           <a:lstStyle/>
           <a:p>
-            <a:r>
-              <a:rPr lang="en-US" dirty="0"/>
-              <a:t/>
-            </a:r>
             <a:endParaRPr lang="en-US" dirty="0"/>
           </a:p>
         </p:txBody>
@@ -1161,10 +927,6 @@
           <a:bodyPr/>
           <a:lstStyle/>
           <a:p>
-            <a:r>
-              <a:rPr lang="en-US" dirty="0"/>
-              <a:t/>
-            </a:r>
             <a:endParaRPr lang="en-US" dirty="0"/>
           </a:p>
         </p:txBody>
@@ -1249,10 +1011,6 @@
           <a:bodyPr/>
           <a:lstStyle/>
           <a:p>
-            <a:r>
-              <a:rPr lang="en-US" dirty="0"/>
-              <a:t/>
-            </a:r>
             <a:endParaRPr lang="en-US" dirty="0"/>
           </a:p>
         </p:txBody>
@@ -1337,10 +1095,6 @@
           <a:bodyPr/>
           <a:lstStyle/>
           <a:p>
-            <a:r>
-              <a:rPr lang="en-US" dirty="0"/>
-              <a:t/>
-            </a:r>
             <a:endParaRPr lang="en-US" dirty="0"/>
           </a:p>
         </p:txBody>
@@ -1425,10 +1179,6 @@
           <a:bodyPr/>
           <a:lstStyle/>
           <a:p>
-            <a:r>
-              <a:rPr lang="en-US" dirty="0"/>
-              <a:t/>
-            </a:r>
             <a:endParaRPr lang="en-US" dirty="0"/>
           </a:p>
         </p:txBody>
@@ -1513,10 +1263,6 @@
           <a:bodyPr/>
           <a:lstStyle/>
           <a:p>
-            <a:r>
-              <a:rPr lang="en-US" dirty="0"/>
-              <a:t/>
-            </a:r>
             <a:endParaRPr lang="en-US" dirty="0"/>
           </a:p>
         </p:txBody>
@@ -1601,10 +1347,6 @@
           <a:bodyPr/>
           <a:lstStyle/>
           <a:p>
-            <a:r>
-              <a:rPr lang="en-US" dirty="0"/>
-              <a:t/>
-            </a:r>
             <a:endParaRPr lang="en-US" dirty="0"/>
           </a:p>
         </p:txBody>
@@ -1689,10 +1431,6 @@
           <a:bodyPr/>
           <a:lstStyle/>
           <a:p>
-            <a:r>
-              <a:rPr lang="en-US" dirty="0"/>
-              <a:t/>
-            </a:r>
             <a:endParaRPr lang="en-US" dirty="0"/>
           </a:p>
         </p:txBody>
@@ -1777,10 +1515,6 @@
           <a:bodyPr/>
           <a:lstStyle/>
           <a:p>
-            <a:r>
-              <a:rPr lang="en-US" dirty="0"/>
-              <a:t/>
-            </a:r>
             <a:endParaRPr lang="en-US" dirty="0"/>
           </a:p>
         </p:txBody>
@@ -1865,10 +1599,6 @@
           <a:bodyPr/>
           <a:lstStyle/>
           <a:p>
-            <a:r>
-              <a:rPr lang="en-US" dirty="0"/>
-              <a:t/>
-            </a:r>
             <a:endParaRPr lang="en-US" dirty="0"/>
           </a:p>
         </p:txBody>
@@ -1953,10 +1683,6 @@
           <a:bodyPr/>
           <a:lstStyle/>
           <a:p>
-            <a:r>
-              <a:rPr lang="en-US" dirty="0"/>
-              <a:t/>
-            </a:r>
             <a:endParaRPr lang="en-US" dirty="0"/>
           </a:p>
         </p:txBody>
@@ -2041,10 +1767,6 @@
           <a:bodyPr/>
           <a:lstStyle/>
           <a:p>
-            <a:r>
-              <a:rPr lang="en-US" dirty="0"/>
-              <a:t/>
-            </a:r>
             <a:endParaRPr lang="en-US" dirty="0"/>
           </a:p>
         </p:txBody>
@@ -2129,10 +1851,6 @@
           <a:bodyPr/>
           <a:lstStyle/>
           <a:p>
-            <a:r>
-              <a:rPr lang="en-US" dirty="0"/>
-              <a:t/>
-            </a:r>
             <a:endParaRPr lang="en-US" dirty="0"/>
           </a:p>
         </p:txBody>
@@ -2217,10 +1935,6 @@
           <a:bodyPr/>
           <a:lstStyle/>
           <a:p>
-            <a:r>
-              <a:rPr lang="en-US" dirty="0"/>
-              <a:t/>
-            </a:r>
             <a:endParaRPr lang="en-US" dirty="0"/>
           </a:p>
         </p:txBody>
@@ -2294,6 +2008,11 @@
 <file path=ppt/slideMasters/slideMaster1.xml><?xml version="1.0" encoding="utf-8"?>
 <p:sldMaster xmlns:a="http://schemas.openxmlformats.org/drawingml/2006/main" xmlns:r="http://schemas.openxmlformats.org/officeDocument/2006/relationships" xmlns:p="http://schemas.openxmlformats.org/presentationml/2006/main">
   <p:cSld>
+    <p:bg>
+      <p:bgRef idx="1001">
+        <a:schemeClr val="bg1"/>
+      </p:bgRef>
+    </p:bg>
     <p:spTree>
       <p:nvGrpSpPr>
         <p:cNvPr id="1" name=""/>
@@ -2576,6 +2295,7 @@
         <a:solidFill>
           <a:srgbClr val="0A2A3D"/>
         </a:solidFill>
+        <a:effectLst/>
       </p:bgPr>
     </p:bg>
     <p:spTree>
@@ -2657,11 +2377,11 @@
           <a:bodyPr wrap="square" rtlCol="0" anchor="ctr"/>
           <a:lstStyle/>
           <a:p>
-            <a:pPr indent="0" marL="0">
-              <a:buNone/>
-            </a:pPr>
-            <a:r>
-              <a:rPr lang="en-US" sz="1400" b="1" spc="300" kern="0" dirty="0">
+            <a:pPr marL="0" indent="0">
+              <a:buNone/>
+            </a:pPr>
+            <a:r>
+              <a:rPr lang="en-US" sz="1400" b="1" kern="0" spc="300" dirty="0">
                 <a:solidFill>
                   <a:srgbClr val="02C39A"/>
                 </a:solidFill>
@@ -2696,7 +2416,7 @@
           <a:bodyPr wrap="square" rtlCol="0" anchor="ctr"/>
           <a:lstStyle/>
           <a:p>
-            <a:pPr indent="0" marL="0">
+            <a:pPr marL="0" indent="0">
               <a:buNone/>
             </a:pPr>
             <a:r>
@@ -2735,7 +2455,7 @@
           <a:bodyPr wrap="square" rtlCol="0" anchor="ctr"/>
           <a:lstStyle/>
           <a:p>
-            <a:pPr indent="0" marL="0">
+            <a:pPr marL="0" indent="0">
               <a:buNone/>
             </a:pPr>
             <a:r>
@@ -2797,11 +2517,11 @@
           <a:bodyPr wrap="square" rtlCol="0" anchor="ctr"/>
           <a:lstStyle/>
           <a:p>
-            <a:pPr indent="0" marL="0">
-              <a:buNone/>
-            </a:pPr>
-            <a:r>
-              <a:rPr lang="en-US" sz="1000" b="1" spc="200" kern="0" dirty="0">
+            <a:pPr marL="0" indent="0">
+              <a:buNone/>
+            </a:pPr>
+            <a:r>
+              <a:rPr lang="en-US" sz="1000" b="1" kern="0" spc="200" dirty="0">
                 <a:solidFill>
                   <a:srgbClr val="02C39A"/>
                 </a:solidFill>
@@ -2836,7 +2556,7 @@
           <a:bodyPr wrap="square" rtlCol="0" anchor="ctr"/>
           <a:lstStyle/>
           <a:p>
-            <a:pPr indent="0" marL="0">
+            <a:pPr marL="0" indent="0">
               <a:spcAft>
                 <a:spcPts val="400"/>
               </a:spcAft>
@@ -2856,7 +2576,7 @@
             <a:endParaRPr lang="en-US" sz="1400" dirty="0"/>
           </a:p>
           <a:p>
-            <a:pPr indent="0" marL="0">
+            <a:pPr marL="0" indent="0">
               <a:spcAft>
                 <a:spcPts val="400"/>
               </a:spcAft>
@@ -2876,7 +2596,7 @@
             <a:endParaRPr lang="en-US" sz="1400" dirty="0"/>
           </a:p>
           <a:p>
-            <a:pPr indent="0" marL="0">
+            <a:pPr marL="0" indent="0">
               <a:spcAft>
                 <a:spcPts val="400"/>
               </a:spcAft>
@@ -2918,7 +2638,7 @@
           <a:bodyPr wrap="square" rtlCol="0" anchor="ctr"/>
           <a:lstStyle/>
           <a:p>
-            <a:pPr indent="0" marL="0">
+            <a:pPr marL="0" indent="0">
               <a:buNone/>
             </a:pPr>
             <a:r>
@@ -2957,7 +2677,7 @@
           <a:bodyPr wrap="square" rtlCol="0" anchor="ctr"/>
           <a:lstStyle/>
           <a:p>
-            <a:pPr indent="0" marL="0">
+            <a:pPr marL="0" indent="0">
               <a:buNone/>
             </a:pPr>
             <a:r>
@@ -2991,6 +2711,7 @@
         <a:solidFill>
           <a:srgbClr val="0A2A3D"/>
         </a:solidFill>
+        <a:effectLst/>
       </p:bgPr>
     </p:bg>
     <p:spTree>
@@ -3028,11 +2749,11 @@
           <a:bodyPr wrap="square" rtlCol="0" anchor="ctr"/>
           <a:lstStyle/>
           <a:p>
-            <a:pPr indent="0" marL="0">
-              <a:buNone/>
-            </a:pPr>
-            <a:r>
-              <a:rPr lang="en-US" sz="1200" b="1" spc="200" kern="0" dirty="0">
+            <a:pPr marL="0" indent="0">
+              <a:buNone/>
+            </a:pPr>
+            <a:r>
+              <a:rPr lang="en-US" sz="1200" b="1" kern="0" spc="200" dirty="0">
                 <a:solidFill>
                   <a:srgbClr val="02C39A"/>
                 </a:solidFill>
@@ -3067,7 +2788,7 @@
           <a:bodyPr wrap="square" rtlCol="0" anchor="ctr"/>
           <a:lstStyle/>
           <a:p>
-            <a:pPr algn="l" indent="0" marL="0">
+            <a:pPr marL="0" indent="0" algn="l">
               <a:buNone/>
             </a:pPr>
             <a:r>
@@ -3106,7 +2827,7 @@
           <a:bodyPr wrap="square" rtlCol="0" anchor="ctr"/>
           <a:lstStyle/>
           <a:p>
-            <a:pPr indent="0" marL="0">
+            <a:pPr marL="0" indent="0">
               <a:buNone/>
             </a:pPr>
             <a:r>
@@ -3165,7 +2886,7 @@
           <a:bodyPr wrap="square" rtlCol="0" anchor="ctr"/>
           <a:lstStyle/>
           <a:p>
-            <a:pPr algn="ctr" indent="0" marL="0">
+            <a:pPr marL="0" indent="0" algn="ctr">
               <a:buNone/>
             </a:pPr>
             <a:r>
@@ -3204,7 +2925,7 @@
           <a:bodyPr wrap="square" rtlCol="0" anchor="ctr"/>
           <a:lstStyle/>
           <a:p>
-            <a:pPr algn="ctr" indent="0" marL="0">
+            <a:pPr marL="0" indent="0" algn="ctr">
               <a:buNone/>
             </a:pPr>
             <a:r>
@@ -3243,7 +2964,7 @@
           <a:bodyPr wrap="square" rtlCol="0" anchor="ctr"/>
           <a:lstStyle/>
           <a:p>
-            <a:pPr algn="ctr" indent="0" marL="0">
+            <a:pPr marL="0" indent="0" algn="ctr">
               <a:buNone/>
             </a:pPr>
             <a:r>
@@ -3302,7 +3023,7 @@
           <a:bodyPr wrap="square" rtlCol="0" anchor="ctr"/>
           <a:lstStyle/>
           <a:p>
-            <a:pPr algn="ctr" indent="0" marL="0">
+            <a:pPr marL="0" indent="0" algn="ctr">
               <a:buNone/>
             </a:pPr>
             <a:r>
@@ -3341,7 +3062,7 @@
           <a:bodyPr wrap="square" rtlCol="0" anchor="ctr"/>
           <a:lstStyle/>
           <a:p>
-            <a:pPr algn="ctr" indent="0" marL="0">
+            <a:pPr marL="0" indent="0" algn="ctr">
               <a:buNone/>
             </a:pPr>
             <a:r>
@@ -3380,7 +3101,7 @@
           <a:bodyPr wrap="square" rtlCol="0" anchor="ctr"/>
           <a:lstStyle/>
           <a:p>
-            <a:pPr algn="ctr" indent="0" marL="0">
+            <a:pPr marL="0" indent="0" algn="ctr">
               <a:buNone/>
             </a:pPr>
             <a:r>
@@ -3439,7 +3160,7 @@
           <a:bodyPr wrap="square" rtlCol="0" anchor="ctr"/>
           <a:lstStyle/>
           <a:p>
-            <a:pPr indent="0" marL="0">
+            <a:pPr marL="0" indent="0">
               <a:buNone/>
             </a:pPr>
             <a:r>
@@ -3478,7 +3199,7 @@
           <a:bodyPr wrap="square" rtlCol="0" anchor="ctr"/>
           <a:lstStyle/>
           <a:p>
-            <a:pPr indent="0" marL="0">
+            <a:pPr marL="0" indent="0">
               <a:buNone/>
             </a:pPr>
             <a:r>
@@ -3517,7 +3238,7 @@
           <a:bodyPr wrap="square" rtlCol="0" anchor="ctr"/>
           <a:lstStyle/>
           <a:p>
-            <a:pPr algn="r" indent="0" marL="0">
+            <a:pPr marL="0" indent="0" algn="r">
               <a:buNone/>
             </a:pPr>
             <a:r>
@@ -3551,6 +3272,7 @@
         <a:solidFill>
           <a:srgbClr val="FFFFFF"/>
         </a:solidFill>
+        <a:effectLst/>
       </p:bgPr>
     </p:bg>
     <p:spTree>
@@ -3588,11 +3310,11 @@
           <a:bodyPr wrap="square" rtlCol="0" anchor="ctr"/>
           <a:lstStyle/>
           <a:p>
-            <a:pPr indent="0" marL="0">
-              <a:buNone/>
-            </a:pPr>
-            <a:r>
-              <a:rPr lang="en-US" sz="1200" b="1" spc="200" kern="0" dirty="0">
+            <a:pPr marL="0" indent="0">
+              <a:buNone/>
+            </a:pPr>
+            <a:r>
+              <a:rPr lang="en-US" sz="1200" b="1" kern="0" spc="200" dirty="0">
                 <a:solidFill>
                   <a:srgbClr val="1C7293"/>
                 </a:solidFill>
@@ -3627,7 +3349,7 @@
           <a:bodyPr wrap="square" rtlCol="0" anchor="ctr"/>
           <a:lstStyle/>
           <a:p>
-            <a:pPr algn="l" indent="0" marL="0">
+            <a:pPr marL="0" indent="0" algn="l">
               <a:buNone/>
             </a:pPr>
             <a:r>
@@ -3666,7 +3388,7 @@
           <a:bodyPr wrap="square" rtlCol="0" anchor="ctr"/>
           <a:lstStyle/>
           <a:p>
-            <a:pPr indent="0" marL="0">
+            <a:pPr marL="0" indent="0">
               <a:buNone/>
             </a:pPr>
             <a:r>
@@ -3725,11 +3447,11 @@
           <a:bodyPr wrap="square" rtlCol="0" anchor="ctr"/>
           <a:lstStyle/>
           <a:p>
-            <a:pPr indent="0" marL="0">
-              <a:buNone/>
-            </a:pPr>
-            <a:r>
-              <a:rPr lang="en-US" sz="1050" b="1" spc="100" kern="0" dirty="0">
+            <a:pPr marL="0" indent="0">
+              <a:buNone/>
+            </a:pPr>
+            <a:r>
+              <a:rPr lang="en-US" sz="1050" b="1" kern="0" spc="100" dirty="0">
                 <a:solidFill>
                   <a:srgbClr val="1C7293"/>
                 </a:solidFill>
@@ -3764,7 +3486,7 @@
           <a:bodyPr wrap="square" rtlCol="0" anchor="ctr"/>
           <a:lstStyle/>
           <a:p>
-            <a:pPr indent="0" marL="0">
+            <a:pPr marL="0" indent="0">
               <a:buNone/>
             </a:pPr>
             <a:r>
@@ -3803,7 +3525,7 @@
           <a:bodyPr wrap="square" rtlCol="0" anchor="ctr"/>
           <a:lstStyle/>
           <a:p>
-            <a:pPr indent="0" marL="0">
+            <a:pPr marL="0" indent="0">
               <a:lnSpc>
                 <a:spcPct val="115000"/>
               </a:lnSpc>
@@ -3865,11 +3587,11 @@
           <a:bodyPr wrap="square" rtlCol="0" anchor="ctr"/>
           <a:lstStyle/>
           <a:p>
-            <a:pPr indent="0" marL="0">
-              <a:buNone/>
-            </a:pPr>
-            <a:r>
-              <a:rPr lang="en-US" sz="1050" b="1" spc="100" kern="0" dirty="0">
+            <a:pPr marL="0" indent="0">
+              <a:buNone/>
+            </a:pPr>
+            <a:r>
+              <a:rPr lang="en-US" sz="1050" b="1" kern="0" spc="100" dirty="0">
                 <a:solidFill>
                   <a:srgbClr val="1C7293"/>
                 </a:solidFill>
@@ -3904,7 +3626,7 @@
           <a:bodyPr wrap="square" rtlCol="0" anchor="ctr"/>
           <a:lstStyle/>
           <a:p>
-            <a:pPr indent="0" marL="0">
+            <a:pPr marL="0" indent="0">
               <a:buNone/>
             </a:pPr>
             <a:r>
@@ -3943,7 +3665,7 @@
           <a:bodyPr wrap="square" rtlCol="0" anchor="ctr"/>
           <a:lstStyle/>
           <a:p>
-            <a:pPr indent="0" marL="0">
+            <a:pPr marL="0" indent="0">
               <a:lnSpc>
                 <a:spcPct val="115000"/>
               </a:lnSpc>
@@ -4005,11 +3727,11 @@
           <a:bodyPr wrap="square" rtlCol="0" anchor="ctr"/>
           <a:lstStyle/>
           <a:p>
-            <a:pPr indent="0" marL="0">
-              <a:buNone/>
-            </a:pPr>
-            <a:r>
-              <a:rPr lang="en-US" sz="1050" b="1" spc="100" kern="0" dirty="0">
+            <a:pPr marL="0" indent="0">
+              <a:buNone/>
+            </a:pPr>
+            <a:r>
+              <a:rPr lang="en-US" sz="1050" b="1" kern="0" spc="100" dirty="0">
                 <a:solidFill>
                   <a:srgbClr val="1C7293"/>
                 </a:solidFill>
@@ -4044,7 +3766,7 @@
           <a:bodyPr wrap="square" rtlCol="0" anchor="ctr"/>
           <a:lstStyle/>
           <a:p>
-            <a:pPr indent="0" marL="0">
+            <a:pPr marL="0" indent="0">
               <a:buNone/>
             </a:pPr>
             <a:r>
@@ -4083,7 +3805,7 @@
           <a:bodyPr wrap="square" rtlCol="0" anchor="ctr"/>
           <a:lstStyle/>
           <a:p>
-            <a:pPr indent="0" marL="0">
+            <a:pPr marL="0" indent="0">
               <a:lnSpc>
                 <a:spcPct val="115000"/>
               </a:lnSpc>
@@ -4125,7 +3847,7 @@
           <a:bodyPr wrap="square" rtlCol="0" anchor="ctr"/>
           <a:lstStyle/>
           <a:p>
-            <a:pPr indent="0" marL="0">
+            <a:pPr marL="0" indent="0">
               <a:buNone/>
             </a:pPr>
             <a:r>
@@ -4164,7 +3886,7 @@
           <a:bodyPr wrap="square" rtlCol="0" anchor="ctr"/>
           <a:lstStyle/>
           <a:p>
-            <a:pPr algn="r" indent="0" marL="0">
+            <a:pPr marL="0" indent="0" algn="r">
               <a:buNone/>
             </a:pPr>
             <a:r>
@@ -4198,6 +3920,7 @@
         <a:solidFill>
           <a:srgbClr val="0A2A3D"/>
         </a:solidFill>
+        <a:effectLst/>
       </p:bgPr>
     </p:bg>
     <p:spTree>
@@ -4235,11 +3958,11 @@
           <a:bodyPr wrap="square" rtlCol="0" anchor="ctr"/>
           <a:lstStyle/>
           <a:p>
-            <a:pPr indent="0" marL="0">
-              <a:buNone/>
-            </a:pPr>
-            <a:r>
-              <a:rPr lang="en-US" sz="1200" b="1" spc="200" kern="0" dirty="0">
+            <a:pPr marL="0" indent="0">
+              <a:buNone/>
+            </a:pPr>
+            <a:r>
+              <a:rPr lang="en-US" sz="1200" b="1" kern="0" spc="200" dirty="0">
                 <a:solidFill>
                   <a:srgbClr val="02C39A"/>
                 </a:solidFill>
@@ -4274,7 +3997,7 @@
           <a:bodyPr wrap="square" rtlCol="0" anchor="ctr"/>
           <a:lstStyle/>
           <a:p>
-            <a:pPr algn="l" indent="0" marL="0">
+            <a:pPr marL="0" indent="0" algn="l">
               <a:buNone/>
             </a:pPr>
             <a:r>
@@ -4333,7 +4056,7 @@
           <a:bodyPr wrap="square" rtlCol="0" anchor="ctr"/>
           <a:lstStyle/>
           <a:p>
-            <a:pPr algn="ctr" indent="0" marL="0">
+            <a:pPr marL="0" indent="0" algn="ctr">
               <a:buNone/>
             </a:pPr>
             <a:r>
@@ -4372,7 +4095,7 @@
           <a:bodyPr wrap="square" rtlCol="0" anchor="ctr"/>
           <a:lstStyle/>
           <a:p>
-            <a:pPr indent="0" marL="0">
+            <a:pPr marL="0" indent="0">
               <a:buNone/>
             </a:pPr>
             <a:r>
@@ -4411,7 +4134,7 @@
           <a:bodyPr wrap="square" rtlCol="0" anchor="ctr"/>
           <a:lstStyle/>
           <a:p>
-            <a:pPr indent="0" marL="0">
+            <a:pPr marL="0" indent="0">
               <a:buNone/>
             </a:pPr>
             <a:r>
@@ -4470,7 +4193,7 @@
           <a:bodyPr wrap="square" rtlCol="0" anchor="ctr"/>
           <a:lstStyle/>
           <a:p>
-            <a:pPr algn="ctr" indent="0" marL="0">
+            <a:pPr marL="0" indent="0" algn="ctr">
               <a:buNone/>
             </a:pPr>
             <a:r>
@@ -4509,7 +4232,7 @@
           <a:bodyPr wrap="square" rtlCol="0" anchor="ctr"/>
           <a:lstStyle/>
           <a:p>
-            <a:pPr indent="0" marL="0">
+            <a:pPr marL="0" indent="0">
               <a:buNone/>
             </a:pPr>
             <a:r>
@@ -4548,7 +4271,7 @@
           <a:bodyPr wrap="square" rtlCol="0" anchor="ctr"/>
           <a:lstStyle/>
           <a:p>
-            <a:pPr indent="0" marL="0">
+            <a:pPr marL="0" indent="0">
               <a:buNone/>
             </a:pPr>
             <a:r>
@@ -4607,7 +4330,7 @@
           <a:bodyPr wrap="square" rtlCol="0" anchor="ctr"/>
           <a:lstStyle/>
           <a:p>
-            <a:pPr algn="ctr" indent="0" marL="0">
+            <a:pPr marL="0" indent="0" algn="ctr">
               <a:buNone/>
             </a:pPr>
             <a:r>
@@ -4646,7 +4369,7 @@
           <a:bodyPr wrap="square" rtlCol="0" anchor="ctr"/>
           <a:lstStyle/>
           <a:p>
-            <a:pPr indent="0" marL="0">
+            <a:pPr marL="0" indent="0">
               <a:buNone/>
             </a:pPr>
             <a:r>
@@ -4685,7 +4408,7 @@
           <a:bodyPr wrap="square" rtlCol="0" anchor="ctr"/>
           <a:lstStyle/>
           <a:p>
-            <a:pPr indent="0" marL="0">
+            <a:pPr marL="0" indent="0">
               <a:buNone/>
             </a:pPr>
             <a:r>
@@ -4744,7 +4467,7 @@
           <a:bodyPr wrap="square" rtlCol="0" anchor="ctr"/>
           <a:lstStyle/>
           <a:p>
-            <a:pPr algn="ctr" indent="0" marL="0">
+            <a:pPr marL="0" indent="0" algn="ctr">
               <a:buNone/>
             </a:pPr>
             <a:r>
@@ -4783,7 +4506,7 @@
           <a:bodyPr wrap="square" rtlCol="0" anchor="ctr"/>
           <a:lstStyle/>
           <a:p>
-            <a:pPr indent="0" marL="0">
+            <a:pPr marL="0" indent="0">
               <a:buNone/>
             </a:pPr>
             <a:r>
@@ -4822,7 +4545,7 @@
           <a:bodyPr wrap="square" rtlCol="0" anchor="ctr"/>
           <a:lstStyle/>
           <a:p>
-            <a:pPr indent="0" marL="0">
+            <a:pPr marL="0" indent="0">
               <a:buNone/>
             </a:pPr>
             <a:r>
@@ -4861,7 +4584,7 @@
           <a:bodyPr wrap="square" rtlCol="0" anchor="ctr"/>
           <a:lstStyle/>
           <a:p>
-            <a:pPr indent="0" marL="0">
+            <a:pPr marL="0" indent="0">
               <a:buNone/>
             </a:pPr>
             <a:r>
@@ -4900,7 +4623,7 @@
           <a:bodyPr wrap="square" rtlCol="0" anchor="ctr"/>
           <a:lstStyle/>
           <a:p>
-            <a:pPr algn="r" indent="0" marL="0">
+            <a:pPr marL="0" indent="0" algn="r">
               <a:buNone/>
             </a:pPr>
             <a:r>
@@ -4934,6 +4657,7 @@
         <a:solidFill>
           <a:srgbClr val="FFFFFF"/>
         </a:solidFill>
+        <a:effectLst/>
       </p:bgPr>
     </p:bg>
     <p:spTree>
@@ -4971,11 +4695,11 @@
           <a:bodyPr wrap="square" rtlCol="0" anchor="ctr"/>
           <a:lstStyle/>
           <a:p>
-            <a:pPr indent="0" marL="0">
-              <a:buNone/>
-            </a:pPr>
-            <a:r>
-              <a:rPr lang="en-US" sz="1200" b="1" spc="200" kern="0" dirty="0">
+            <a:pPr marL="0" indent="0">
+              <a:buNone/>
+            </a:pPr>
+            <a:r>
+              <a:rPr lang="en-US" sz="1200" b="1" kern="0" spc="200" dirty="0">
                 <a:solidFill>
                   <a:srgbClr val="1C7293"/>
                 </a:solidFill>
@@ -5010,7 +4734,7 @@
           <a:bodyPr wrap="square" rtlCol="0" anchor="ctr"/>
           <a:lstStyle/>
           <a:p>
-            <a:pPr algn="l" indent="0" marL="0">
+            <a:pPr marL="0" indent="0" algn="l">
               <a:buNone/>
             </a:pPr>
             <a:r>
@@ -5049,7 +4773,7 @@
           <a:bodyPr wrap="square" rtlCol="0" anchor="ctr"/>
           <a:lstStyle/>
           <a:p>
-            <a:pPr indent="0" marL="0">
+            <a:pPr marL="0" indent="0">
               <a:buNone/>
             </a:pPr>
             <a:r>
@@ -5108,7 +4832,7 @@
           <a:bodyPr wrap="square" rtlCol="0" anchor="ctr"/>
           <a:lstStyle/>
           <a:p>
-            <a:pPr indent="0" marL="0">
+            <a:pPr marL="0" indent="0">
               <a:buNone/>
             </a:pPr>
             <a:r>
@@ -5147,7 +4871,7 @@
           <a:bodyPr wrap="square" rtlCol="0" anchor="ctr"/>
           <a:lstStyle/>
           <a:p>
-            <a:pPr indent="0" marL="0">
+            <a:pPr marL="0" indent="0">
               <a:buNone/>
             </a:pPr>
             <a:r>
@@ -5186,7 +4910,7 @@
           <a:bodyPr wrap="square" rtlCol="0" anchor="ctr"/>
           <a:lstStyle/>
           <a:p>
-            <a:pPr indent="0" marL="0">
+            <a:pPr marL="0" indent="0">
               <a:buNone/>
             </a:pPr>
             <a:r>
@@ -5245,7 +4969,7 @@
           <a:bodyPr wrap="square" rtlCol="0" anchor="ctr"/>
           <a:lstStyle/>
           <a:p>
-            <a:pPr indent="0" marL="0">
+            <a:pPr marL="0" indent="0">
               <a:buNone/>
             </a:pPr>
             <a:r>
@@ -5284,7 +5008,7 @@
           <a:bodyPr wrap="square" rtlCol="0" anchor="ctr"/>
           <a:lstStyle/>
           <a:p>
-            <a:pPr indent="0" marL="0">
+            <a:pPr marL="0" indent="0">
               <a:buNone/>
             </a:pPr>
             <a:r>
@@ -5323,7 +5047,7 @@
           <a:bodyPr wrap="square" rtlCol="0" anchor="ctr"/>
           <a:lstStyle/>
           <a:p>
-            <a:pPr indent="0" marL="0">
+            <a:pPr marL="0" indent="0">
               <a:buNone/>
             </a:pPr>
             <a:r>
@@ -5382,7 +5106,7 @@
           <a:bodyPr wrap="square" rtlCol="0" anchor="ctr"/>
           <a:lstStyle/>
           <a:p>
-            <a:pPr indent="0" marL="0">
+            <a:pPr marL="0" indent="0">
               <a:buNone/>
             </a:pPr>
             <a:r>
@@ -5421,7 +5145,7 @@
           <a:bodyPr wrap="square" rtlCol="0" anchor="ctr"/>
           <a:lstStyle/>
           <a:p>
-            <a:pPr indent="0" marL="0">
+            <a:pPr marL="0" indent="0">
               <a:buNone/>
             </a:pPr>
             <a:r>
@@ -5460,7 +5184,7 @@
           <a:bodyPr wrap="square" rtlCol="0" anchor="ctr"/>
           <a:lstStyle/>
           <a:p>
-            <a:pPr indent="0" marL="0">
+            <a:pPr marL="0" indent="0">
               <a:buNone/>
             </a:pPr>
             <a:r>
@@ -5519,7 +5243,7 @@
           <a:bodyPr wrap="square" rtlCol="0" anchor="ctr"/>
           <a:lstStyle/>
           <a:p>
-            <a:pPr indent="0" marL="0">
+            <a:pPr marL="0" indent="0">
               <a:buNone/>
             </a:pPr>
             <a:r>
@@ -5558,7 +5282,7 @@
           <a:bodyPr wrap="square" rtlCol="0" anchor="ctr"/>
           <a:lstStyle/>
           <a:p>
-            <a:pPr indent="0" marL="0">
+            <a:pPr marL="0" indent="0">
               <a:buNone/>
             </a:pPr>
             <a:r>
@@ -5597,7 +5321,7 @@
           <a:bodyPr wrap="square" rtlCol="0" anchor="ctr"/>
           <a:lstStyle/>
           <a:p>
-            <a:pPr indent="0" marL="0">
+            <a:pPr marL="0" indent="0">
               <a:buNone/>
             </a:pPr>
             <a:r>
@@ -5636,7 +5360,7 @@
           <a:bodyPr wrap="square" rtlCol="0" anchor="ctr"/>
           <a:lstStyle/>
           <a:p>
-            <a:pPr indent="0" marL="0">
+            <a:pPr marL="0" indent="0">
               <a:buNone/>
             </a:pPr>
             <a:r>
@@ -5675,7 +5399,7 @@
           <a:bodyPr wrap="square" rtlCol="0" anchor="ctr"/>
           <a:lstStyle/>
           <a:p>
-            <a:pPr indent="0" marL="0">
+            <a:pPr marL="0" indent="0">
               <a:buNone/>
             </a:pPr>
             <a:r>
@@ -5714,7 +5438,7 @@
           <a:bodyPr wrap="square" rtlCol="0" anchor="ctr"/>
           <a:lstStyle/>
           <a:p>
-            <a:pPr algn="r" indent="0" marL="0">
+            <a:pPr marL="0" indent="0" algn="r">
               <a:buNone/>
             </a:pPr>
             <a:r>
@@ -5748,6 +5472,7 @@
         <a:solidFill>
           <a:srgbClr val="FFFFFF"/>
         </a:solidFill>
+        <a:effectLst/>
       </p:bgPr>
     </p:bg>
     <p:spTree>
@@ -5785,11 +5510,11 @@
           <a:bodyPr wrap="square" rtlCol="0" anchor="ctr"/>
           <a:lstStyle/>
           <a:p>
-            <a:pPr indent="0" marL="0">
-              <a:buNone/>
-            </a:pPr>
-            <a:r>
-              <a:rPr lang="en-US" sz="1200" b="1" spc="200" kern="0" dirty="0">
+            <a:pPr marL="0" indent="0">
+              <a:buNone/>
+            </a:pPr>
+            <a:r>
+              <a:rPr lang="en-US" sz="1200" b="1" kern="0" spc="200" dirty="0">
                 <a:solidFill>
                   <a:srgbClr val="1C7293"/>
                 </a:solidFill>
@@ -5824,7 +5549,7 @@
           <a:bodyPr wrap="square" rtlCol="0" anchor="ctr"/>
           <a:lstStyle/>
           <a:p>
-            <a:pPr algn="l" indent="0" marL="0">
+            <a:pPr marL="0" indent="0" algn="l">
               <a:buNone/>
             </a:pPr>
             <a:r>
@@ -5883,7 +5608,7 @@
           <a:bodyPr wrap="square" rtlCol="0" anchor="ctr"/>
           <a:lstStyle/>
           <a:p>
-            <a:pPr algn="ctr" indent="0" marL="0">
+            <a:pPr marL="0" indent="0" algn="ctr">
               <a:buNone/>
             </a:pPr>
             <a:r>
@@ -5922,7 +5647,7 @@
           <a:bodyPr wrap="square" rtlCol="0" anchor="ctr"/>
           <a:lstStyle/>
           <a:p>
-            <a:pPr algn="ctr" indent="0" marL="0">
+            <a:pPr marL="0" indent="0" algn="ctr">
               <a:buNone/>
             </a:pPr>
             <a:r>
@@ -5981,7 +5706,7 @@
           <a:bodyPr wrap="square" rtlCol="0" anchor="ctr"/>
           <a:lstStyle/>
           <a:p>
-            <a:pPr algn="ctr" indent="0" marL="0">
+            <a:pPr marL="0" indent="0" algn="ctr">
               <a:buNone/>
             </a:pPr>
             <a:r>
@@ -6020,7 +5745,7 @@
           <a:bodyPr wrap="square" rtlCol="0" anchor="ctr"/>
           <a:lstStyle/>
           <a:p>
-            <a:pPr indent="0" marL="0">
+            <a:pPr marL="0" indent="0">
               <a:buNone/>
             </a:pPr>
             <a:r>
@@ -6059,7 +5784,7 @@
           <a:bodyPr wrap="square" rtlCol="0" anchor="ctr"/>
           <a:lstStyle/>
           <a:p>
-            <a:pPr indent="0" marL="0">
+            <a:pPr marL="0" indent="0">
               <a:buNone/>
             </a:pPr>
             <a:r>
@@ -6118,7 +5843,7 @@
           <a:bodyPr wrap="square" rtlCol="0" anchor="ctr"/>
           <a:lstStyle/>
           <a:p>
-            <a:pPr algn="ctr" indent="0" marL="0">
+            <a:pPr marL="0" indent="0" algn="ctr">
               <a:buNone/>
             </a:pPr>
             <a:r>
@@ -6157,7 +5882,7 @@
           <a:bodyPr wrap="square" rtlCol="0" anchor="ctr"/>
           <a:lstStyle/>
           <a:p>
-            <a:pPr indent="0" marL="0">
+            <a:pPr marL="0" indent="0">
               <a:buNone/>
             </a:pPr>
             <a:r>
@@ -6196,7 +5921,7 @@
           <a:bodyPr wrap="square" rtlCol="0" anchor="ctr"/>
           <a:lstStyle/>
           <a:p>
-            <a:pPr indent="0" marL="0">
+            <a:pPr marL="0" indent="0">
               <a:buNone/>
             </a:pPr>
             <a:r>
@@ -6255,7 +5980,7 @@
           <a:bodyPr wrap="square" rtlCol="0" anchor="ctr"/>
           <a:lstStyle/>
           <a:p>
-            <a:pPr algn="ctr" indent="0" marL="0">
+            <a:pPr marL="0" indent="0" algn="ctr">
               <a:buNone/>
             </a:pPr>
             <a:r>
@@ -6294,7 +6019,7 @@
           <a:bodyPr wrap="square" rtlCol="0" anchor="ctr"/>
           <a:lstStyle/>
           <a:p>
-            <a:pPr indent="0" marL="0">
+            <a:pPr marL="0" indent="0">
               <a:buNone/>
             </a:pPr>
             <a:r>
@@ -6333,7 +6058,7 @@
           <a:bodyPr wrap="square" rtlCol="0" anchor="ctr"/>
           <a:lstStyle/>
           <a:p>
-            <a:pPr indent="0" marL="0">
+            <a:pPr marL="0" indent="0">
               <a:buNone/>
             </a:pPr>
             <a:r>
@@ -6392,7 +6117,7 @@
           <a:bodyPr wrap="square" rtlCol="0" anchor="ctr"/>
           <a:lstStyle/>
           <a:p>
-            <a:pPr algn="ctr" indent="0" marL="0">
+            <a:pPr marL="0" indent="0" algn="ctr">
               <a:buNone/>
             </a:pPr>
             <a:r>
@@ -6431,7 +6156,7 @@
           <a:bodyPr wrap="square" rtlCol="0" anchor="ctr"/>
           <a:lstStyle/>
           <a:p>
-            <a:pPr indent="0" marL="0">
+            <a:pPr marL="0" indent="0">
               <a:buNone/>
             </a:pPr>
             <a:r>
@@ -6470,7 +6195,7 @@
           <a:bodyPr wrap="square" rtlCol="0" anchor="ctr"/>
           <a:lstStyle/>
           <a:p>
-            <a:pPr indent="0" marL="0">
+            <a:pPr marL="0" indent="0">
               <a:buNone/>
             </a:pPr>
             <a:r>
@@ -6509,7 +6234,7 @@
           <a:bodyPr wrap="square" rtlCol="0" anchor="ctr"/>
           <a:lstStyle/>
           <a:p>
-            <a:pPr indent="0" marL="0">
+            <a:pPr marL="0" indent="0">
               <a:buNone/>
             </a:pPr>
             <a:r>
@@ -6548,7 +6273,7 @@
           <a:bodyPr wrap="square" rtlCol="0" anchor="ctr"/>
           <a:lstStyle/>
           <a:p>
-            <a:pPr algn="r" indent="0" marL="0">
+            <a:pPr marL="0" indent="0" algn="r">
               <a:buNone/>
             </a:pPr>
             <a:r>
@@ -6582,6 +6307,7 @@
         <a:solidFill>
           <a:srgbClr val="FFFFFF"/>
         </a:solidFill>
+        <a:effectLst/>
       </p:bgPr>
     </p:bg>
     <p:spTree>
@@ -6619,11 +6345,11 @@
           <a:bodyPr wrap="square" rtlCol="0" anchor="ctr"/>
           <a:lstStyle/>
           <a:p>
-            <a:pPr indent="0" marL="0">
-              <a:buNone/>
-            </a:pPr>
-            <a:r>
-              <a:rPr lang="en-US" sz="1200" b="1" spc="200" kern="0" dirty="0">
+            <a:pPr marL="0" indent="0">
+              <a:buNone/>
+            </a:pPr>
+            <a:r>
+              <a:rPr lang="en-US" sz="1200" b="1" kern="0" spc="200" dirty="0">
                 <a:solidFill>
                   <a:srgbClr val="1C7293"/>
                 </a:solidFill>
@@ -6658,7 +6384,7 @@
           <a:bodyPr wrap="square" rtlCol="0" anchor="ctr"/>
           <a:lstStyle/>
           <a:p>
-            <a:pPr algn="l" indent="0" marL="0">
+            <a:pPr marL="0" indent="0" algn="l">
               <a:buNone/>
             </a:pPr>
             <a:r>
@@ -6717,7 +6443,7 @@
           <a:bodyPr wrap="square" rtlCol="0" anchor="ctr"/>
           <a:lstStyle/>
           <a:p>
-            <a:pPr algn="ctr" indent="0" marL="0">
+            <a:pPr marL="0" indent="0" algn="ctr">
               <a:buNone/>
             </a:pPr>
             <a:r>
@@ -6756,7 +6482,7 @@
           <a:bodyPr wrap="square" rtlCol="0" anchor="ctr"/>
           <a:lstStyle/>
           <a:p>
-            <a:pPr algn="ctr" indent="0" marL="0">
+            <a:pPr marL="0" indent="0" algn="ctr">
               <a:buNone/>
             </a:pPr>
             <a:r>
@@ -6795,7 +6521,7 @@
           <a:bodyPr wrap="square" rtlCol="0" anchor="ctr"/>
           <a:lstStyle/>
           <a:p>
-            <a:pPr algn="ctr" indent="0" marL="0">
+            <a:pPr marL="0" indent="0" algn="ctr">
               <a:buNone/>
             </a:pPr>
             <a:r>
@@ -6854,7 +6580,7 @@
           <a:bodyPr wrap="square" rtlCol="0" anchor="ctr"/>
           <a:lstStyle/>
           <a:p>
-            <a:pPr algn="ctr" indent="0" marL="0">
+            <a:pPr marL="0" indent="0" algn="ctr">
               <a:buNone/>
             </a:pPr>
             <a:r>
@@ -6893,7 +6619,7 @@
           <a:bodyPr wrap="square" rtlCol="0" anchor="ctr"/>
           <a:lstStyle/>
           <a:p>
-            <a:pPr algn="ctr" indent="0" marL="0">
+            <a:pPr marL="0" indent="0" algn="ctr">
               <a:buNone/>
             </a:pPr>
             <a:r>
@@ -6932,7 +6658,7 @@
           <a:bodyPr wrap="square" rtlCol="0" anchor="ctr"/>
           <a:lstStyle/>
           <a:p>
-            <a:pPr algn="ctr" indent="0" marL="0">
+            <a:pPr marL="0" indent="0" algn="ctr">
               <a:buNone/>
             </a:pPr>
             <a:r>
@@ -6991,7 +6717,7 @@
           <a:bodyPr wrap="square" rtlCol="0" anchor="ctr"/>
           <a:lstStyle/>
           <a:p>
-            <a:pPr algn="ctr" indent="0" marL="0">
+            <a:pPr marL="0" indent="0" algn="ctr">
               <a:buNone/>
             </a:pPr>
             <a:r>
@@ -7030,7 +6756,7 @@
           <a:bodyPr wrap="square" rtlCol="0" anchor="ctr"/>
           <a:lstStyle/>
           <a:p>
-            <a:pPr algn="ctr" indent="0" marL="0">
+            <a:pPr marL="0" indent="0" algn="ctr">
               <a:buNone/>
             </a:pPr>
             <a:r>
@@ -7069,7 +6795,7 @@
           <a:bodyPr wrap="square" rtlCol="0" anchor="ctr"/>
           <a:lstStyle/>
           <a:p>
-            <a:pPr algn="ctr" indent="0" marL="0">
+            <a:pPr marL="0" indent="0" algn="ctr">
               <a:buNone/>
             </a:pPr>
             <a:r>
@@ -7108,7 +6834,7 @@
           <a:bodyPr wrap="square" rtlCol="0" anchor="ctr"/>
           <a:lstStyle/>
           <a:p>
-            <a:pPr indent="0" marL="0">
+            <a:pPr marL="0" indent="0">
               <a:buNone/>
             </a:pPr>
             <a:r>
@@ -7147,7 +6873,7 @@
           <a:bodyPr wrap="square" rtlCol="0" anchor="ctr"/>
           <a:lstStyle/>
           <a:p>
-            <a:pPr indent="0" marL="0">
+            <a:pPr marL="0" indent="0">
               <a:buNone/>
             </a:pPr>
             <a:r>
@@ -7186,7 +6912,7 @@
           <a:bodyPr wrap="square" rtlCol="0" anchor="ctr"/>
           <a:lstStyle/>
           <a:p>
-            <a:pPr indent="0" marL="0">
+            <a:pPr marL="0" indent="0">
               <a:buNone/>
             </a:pPr>
             <a:r>
@@ -7225,7 +6951,7 @@
           <a:bodyPr wrap="square" rtlCol="0" anchor="ctr"/>
           <a:lstStyle/>
           <a:p>
-            <a:pPr algn="r" indent="0" marL="0">
+            <a:pPr marL="0" indent="0" algn="r">
               <a:buNone/>
             </a:pPr>
             <a:r>
@@ -7259,6 +6985,7 @@
         <a:solidFill>
           <a:srgbClr val="FFFFFF"/>
         </a:solidFill>
+        <a:effectLst/>
       </p:bgPr>
     </p:bg>
     <p:spTree>
@@ -7296,11 +7023,11 @@
           <a:bodyPr wrap="square" rtlCol="0" anchor="ctr"/>
           <a:lstStyle/>
           <a:p>
-            <a:pPr indent="0" marL="0">
-              <a:buNone/>
-            </a:pPr>
-            <a:r>
-              <a:rPr lang="en-US" sz="1200" b="1" spc="200" kern="0" dirty="0">
+            <a:pPr marL="0" indent="0">
+              <a:buNone/>
+            </a:pPr>
+            <a:r>
+              <a:rPr lang="en-US" sz="1200" b="1" kern="0" spc="200" dirty="0">
                 <a:solidFill>
                   <a:srgbClr val="1C7293"/>
                 </a:solidFill>
@@ -7335,7 +7062,7 @@
           <a:bodyPr wrap="square" rtlCol="0" anchor="ctr"/>
           <a:lstStyle/>
           <a:p>
-            <a:pPr algn="l" indent="0" marL="0">
+            <a:pPr marL="0" indent="0" algn="l">
               <a:buNone/>
             </a:pPr>
             <a:r>
@@ -7394,7 +7121,7 @@
           <a:bodyPr wrap="square" rtlCol="0" anchor="ctr"/>
           <a:lstStyle/>
           <a:p>
-            <a:pPr algn="ctr" indent="0" marL="0">
+            <a:pPr marL="0" indent="0" algn="ctr">
               <a:buNone/>
             </a:pPr>
             <a:r>
@@ -7621,7 +7348,7 @@
           <a:bodyPr wrap="square" rtlCol="0" anchor="ctr"/>
           <a:lstStyle/>
           <a:p>
-            <a:pPr algn="ctr" indent="0" marL="0">
+            <a:pPr marL="0" indent="0" algn="ctr">
               <a:buNone/>
             </a:pPr>
             <a:r>
@@ -7807,7 +7534,7 @@
           <a:bodyPr wrap="square" rtlCol="0" anchor="ctr"/>
           <a:lstStyle/>
           <a:p>
-            <a:pPr indent="0" marL="0">
+            <a:pPr marL="0" indent="0">
               <a:buNone/>
             </a:pPr>
             <a:r>
@@ -7846,7 +7573,7 @@
           <a:bodyPr wrap="square" rtlCol="0" anchor="ctr"/>
           <a:lstStyle/>
           <a:p>
-            <a:pPr algn="r" indent="0" marL="0">
+            <a:pPr marL="0" indent="0" algn="r">
               <a:buNone/>
             </a:pPr>
             <a:r>
@@ -7880,6 +7607,7 @@
         <a:solidFill>
           <a:srgbClr val="0A2A3D"/>
         </a:solidFill>
+        <a:effectLst/>
       </p:bgPr>
     </p:bg>
     <p:spTree>
@@ -7939,7 +7667,7 @@
           <a:bodyPr wrap="square" rtlCol="0" anchor="ctr"/>
           <a:lstStyle/>
           <a:p>
-            <a:pPr indent="0" marL="0">
+            <a:pPr marL="0" indent="0">
               <a:buNone/>
             </a:pPr>
             <a:r>
@@ -7978,7 +7706,7 @@
           <a:bodyPr wrap="square" rtlCol="0" anchor="ctr"/>
           <a:lstStyle/>
           <a:p>
-            <a:pPr indent="0" marL="0">
+            <a:pPr marL="0" indent="0">
               <a:buNone/>
             </a:pPr>
             <a:r>
@@ -8040,7 +7768,7 @@
           <a:bodyPr wrap="square" rtlCol="0" anchor="ctr"/>
           <a:lstStyle/>
           <a:p>
-            <a:pPr indent="0" marL="0">
+            <a:pPr marL="0" indent="0">
               <a:buNone/>
             </a:pPr>
             <a:r>
@@ -8079,7 +7807,7 @@
           <a:bodyPr wrap="square" rtlCol="0" anchor="ctr"/>
           <a:lstStyle/>
           <a:p>
-            <a:pPr indent="0" marL="0">
+            <a:pPr marL="0" indent="0">
               <a:buNone/>
             </a:pPr>
             <a:r>
@@ -8118,7 +7846,7 @@
           <a:bodyPr wrap="square" rtlCol="0" anchor="ctr"/>
           <a:lstStyle/>
           <a:p>
-            <a:pPr indent="0" marL="0">
+            <a:pPr marL="0" indent="0">
               <a:buNone/>
             </a:pPr>
             <a:r>
@@ -8152,6 +7880,7 @@
         <a:solidFill>
           <a:srgbClr val="FFFFFF"/>
         </a:solidFill>
+        <a:effectLst/>
       </p:bgPr>
     </p:bg>
     <p:spTree>
@@ -8189,11 +7918,11 @@
           <a:bodyPr wrap="square" rtlCol="0" anchor="ctr"/>
           <a:lstStyle/>
           <a:p>
-            <a:pPr indent="0" marL="0">
-              <a:buNone/>
-            </a:pPr>
-            <a:r>
-              <a:rPr lang="en-US" sz="1200" b="1" spc="200" kern="0" dirty="0">
+            <a:pPr marL="0" indent="0">
+              <a:buNone/>
+            </a:pPr>
+            <a:r>
+              <a:rPr lang="en-US" sz="1200" b="1" kern="0" spc="200" dirty="0">
                 <a:solidFill>
                   <a:srgbClr val="1C7293"/>
                 </a:solidFill>
@@ -8228,7 +7957,7 @@
           <a:bodyPr wrap="square" rtlCol="0" anchor="ctr"/>
           <a:lstStyle/>
           <a:p>
-            <a:pPr algn="l" indent="0" marL="0">
+            <a:pPr marL="0" indent="0" algn="l">
               <a:buNone/>
             </a:pPr>
             <a:r>
@@ -8267,7 +7996,7 @@
           <a:bodyPr wrap="square" rtlCol="0" anchor="ctr"/>
           <a:lstStyle/>
           <a:p>
-            <a:pPr algn="l" indent="0" marL="0">
+            <a:pPr marL="0" indent="0" algn="l">
               <a:buNone/>
             </a:pPr>
             <a:r>
@@ -8306,7 +8035,7 @@
           <a:bodyPr wrap="square" rtlCol="0" anchor="ctr"/>
           <a:lstStyle/>
           <a:p>
-            <a:pPr indent="0" marL="0">
+            <a:pPr marL="0" indent="0">
               <a:buNone/>
             </a:pPr>
             <a:r>
@@ -8345,7 +8074,7 @@
           <a:bodyPr wrap="square" rtlCol="0" anchor="ctr"/>
           <a:lstStyle/>
           <a:p>
-            <a:pPr indent="0" marL="0">
+            <a:pPr marL="0" indent="0">
               <a:buNone/>
             </a:pPr>
             <a:r>
@@ -8384,7 +8113,7 @@
           <a:bodyPr wrap="square" rtlCol="0" anchor="ctr"/>
           <a:lstStyle/>
           <a:p>
-            <a:pPr algn="l" indent="0" marL="0">
+            <a:pPr marL="0" indent="0" algn="l">
               <a:buNone/>
             </a:pPr>
             <a:r>
@@ -8423,7 +8152,7 @@
           <a:bodyPr wrap="square" rtlCol="0" anchor="ctr"/>
           <a:lstStyle/>
           <a:p>
-            <a:pPr indent="0" marL="0">
+            <a:pPr marL="0" indent="0">
               <a:buNone/>
             </a:pPr>
             <a:r>
@@ -8462,7 +8191,7 @@
           <a:bodyPr wrap="square" rtlCol="0" anchor="ctr"/>
           <a:lstStyle/>
           <a:p>
-            <a:pPr indent="0" marL="0">
+            <a:pPr marL="0" indent="0">
               <a:buNone/>
             </a:pPr>
             <a:r>
@@ -8501,7 +8230,7 @@
           <a:bodyPr wrap="square" rtlCol="0" anchor="ctr"/>
           <a:lstStyle/>
           <a:p>
-            <a:pPr algn="l" indent="0" marL="0">
+            <a:pPr marL="0" indent="0" algn="l">
               <a:buNone/>
             </a:pPr>
             <a:r>
@@ -8540,7 +8269,7 @@
           <a:bodyPr wrap="square" rtlCol="0" anchor="ctr"/>
           <a:lstStyle/>
           <a:p>
-            <a:pPr indent="0" marL="0">
+            <a:pPr marL="0" indent="0">
               <a:buNone/>
             </a:pPr>
             <a:r>
@@ -8579,7 +8308,7 @@
           <a:bodyPr wrap="square" rtlCol="0" anchor="ctr"/>
           <a:lstStyle/>
           <a:p>
-            <a:pPr indent="0" marL="0">
+            <a:pPr marL="0" indent="0">
               <a:buNone/>
             </a:pPr>
             <a:r>
@@ -8618,7 +8347,7 @@
           <a:bodyPr wrap="square" rtlCol="0" anchor="ctr"/>
           <a:lstStyle/>
           <a:p>
-            <a:pPr algn="l" indent="0" marL="0">
+            <a:pPr marL="0" indent="0" algn="l">
               <a:buNone/>
             </a:pPr>
             <a:r>
@@ -8657,7 +8386,7 @@
           <a:bodyPr wrap="square" rtlCol="0" anchor="ctr"/>
           <a:lstStyle/>
           <a:p>
-            <a:pPr indent="0" marL="0">
+            <a:pPr marL="0" indent="0">
               <a:buNone/>
             </a:pPr>
             <a:r>
@@ -8696,7 +8425,7 @@
           <a:bodyPr wrap="square" rtlCol="0" anchor="ctr"/>
           <a:lstStyle/>
           <a:p>
-            <a:pPr indent="0" marL="0">
+            <a:pPr marL="0" indent="0">
               <a:buNone/>
             </a:pPr>
             <a:r>
@@ -8735,7 +8464,7 @@
           <a:bodyPr wrap="square" rtlCol="0" anchor="ctr"/>
           <a:lstStyle/>
           <a:p>
-            <a:pPr algn="l" indent="0" marL="0">
+            <a:pPr marL="0" indent="0" algn="l">
               <a:buNone/>
             </a:pPr>
             <a:r>
@@ -8774,7 +8503,7 @@
           <a:bodyPr wrap="square" rtlCol="0" anchor="ctr"/>
           <a:lstStyle/>
           <a:p>
-            <a:pPr indent="0" marL="0">
+            <a:pPr marL="0" indent="0">
               <a:buNone/>
             </a:pPr>
             <a:r>
@@ -8813,7 +8542,7 @@
           <a:bodyPr wrap="square" rtlCol="0" anchor="ctr"/>
           <a:lstStyle/>
           <a:p>
-            <a:pPr indent="0" marL="0">
+            <a:pPr marL="0" indent="0">
               <a:buNone/>
             </a:pPr>
             <a:r>
@@ -8852,7 +8581,7 @@
           <a:bodyPr wrap="square" rtlCol="0" anchor="ctr"/>
           <a:lstStyle/>
           <a:p>
-            <a:pPr algn="l" indent="0" marL="0">
+            <a:pPr marL="0" indent="0" algn="l">
               <a:buNone/>
             </a:pPr>
             <a:r>
@@ -8891,7 +8620,7 @@
           <a:bodyPr wrap="square" rtlCol="0" anchor="ctr"/>
           <a:lstStyle/>
           <a:p>
-            <a:pPr indent="0" marL="0">
+            <a:pPr marL="0" indent="0">
               <a:buNone/>
             </a:pPr>
             <a:r>
@@ -8930,7 +8659,7 @@
           <a:bodyPr wrap="square" rtlCol="0" anchor="ctr"/>
           <a:lstStyle/>
           <a:p>
-            <a:pPr indent="0" marL="0">
+            <a:pPr marL="0" indent="0">
               <a:buNone/>
             </a:pPr>
             <a:r>
@@ -8969,7 +8698,7 @@
           <a:bodyPr wrap="square" rtlCol="0" anchor="ctr"/>
           <a:lstStyle/>
           <a:p>
-            <a:pPr indent="0" marL="0">
+            <a:pPr marL="0" indent="0">
               <a:buNone/>
             </a:pPr>
             <a:r>
@@ -9008,7 +8737,7 @@
           <a:bodyPr wrap="square" rtlCol="0" anchor="ctr"/>
           <a:lstStyle/>
           <a:p>
-            <a:pPr algn="r" indent="0" marL="0">
+            <a:pPr marL="0" indent="0" algn="r">
               <a:buNone/>
             </a:pPr>
             <a:r>
@@ -9042,6 +8771,7 @@
         <a:solidFill>
           <a:srgbClr val="FFFFFF"/>
         </a:solidFill>
+        <a:effectLst/>
       </p:bgPr>
     </p:bg>
     <p:spTree>
@@ -9079,11 +8809,11 @@
           <a:bodyPr wrap="square" rtlCol="0" anchor="ctr"/>
           <a:lstStyle/>
           <a:p>
-            <a:pPr indent="0" marL="0">
-              <a:buNone/>
-            </a:pPr>
-            <a:r>
-              <a:rPr lang="en-US" sz="1200" b="1" spc="200" kern="0" dirty="0">
+            <a:pPr marL="0" indent="0">
+              <a:buNone/>
+            </a:pPr>
+            <a:r>
+              <a:rPr lang="en-US" sz="1200" b="1" kern="0" spc="200" dirty="0">
                 <a:solidFill>
                   <a:srgbClr val="1C7293"/>
                 </a:solidFill>
@@ -9118,7 +8848,7 @@
           <a:bodyPr wrap="square" rtlCol="0" anchor="ctr"/>
           <a:lstStyle/>
           <a:p>
-            <a:pPr algn="l" indent="0" marL="0">
+            <a:pPr marL="0" indent="0" algn="l">
               <a:buNone/>
             </a:pPr>
             <a:r>
@@ -9177,7 +8907,7 @@
           <a:bodyPr wrap="square" rtlCol="0" anchor="ctr"/>
           <a:lstStyle/>
           <a:p>
-            <a:pPr indent="0" marL="0">
+            <a:pPr marL="0" indent="0">
               <a:buNone/>
             </a:pPr>
             <a:r>
@@ -9342,11 +9072,11 @@
           <a:bodyPr wrap="square" rtlCol="0" anchor="ctr"/>
           <a:lstStyle/>
           <a:p>
-            <a:pPr indent="0" marL="0">
-              <a:buNone/>
-            </a:pPr>
-            <a:r>
-              <a:rPr lang="en-US" sz="1100" b="1" spc="200" kern="0" dirty="0">
+            <a:pPr marL="0" indent="0">
+              <a:buNone/>
+            </a:pPr>
+            <a:r>
+              <a:rPr lang="en-US" sz="1100" b="1" kern="0" spc="200" dirty="0">
                 <a:solidFill>
                   <a:srgbClr val="02C39A"/>
                 </a:solidFill>
@@ -9381,7 +9111,7 @@
           <a:bodyPr wrap="square" rtlCol="0" anchor="ctr"/>
           <a:lstStyle/>
           <a:p>
-            <a:pPr indent="0" marL="0">
+            <a:pPr marL="0" indent="0">
               <a:buNone/>
             </a:pPr>
             <a:r>
@@ -9420,7 +9150,7 @@
           <a:bodyPr wrap="square" rtlCol="0" anchor="ctr"/>
           <a:lstStyle/>
           <a:p>
-            <a:pPr indent="0" marL="0">
+            <a:pPr marL="0" indent="0">
               <a:buNone/>
             </a:pPr>
             <a:r>
@@ -9459,7 +9189,7 @@
           <a:bodyPr wrap="square" rtlCol="0" anchor="ctr"/>
           <a:lstStyle/>
           <a:p>
-            <a:pPr indent="0" marL="0">
+            <a:pPr marL="0" indent="0">
               <a:buNone/>
             </a:pPr>
             <a:r>
@@ -9476,7 +9206,7 @@
             <a:endParaRPr lang="en-US" sz="950" dirty="0"/>
           </a:p>
           <a:p>
-            <a:pPr indent="0" marL="0">
+            <a:pPr marL="0" indent="0">
               <a:buNone/>
             </a:pPr>
             <a:r>
@@ -9515,7 +9245,7 @@
           <a:bodyPr wrap="square" rtlCol="0" anchor="ctr"/>
           <a:lstStyle/>
           <a:p>
-            <a:pPr indent="0" marL="0">
+            <a:pPr marL="0" indent="0">
               <a:buNone/>
             </a:pPr>
             <a:r>
@@ -9554,7 +9284,7 @@
           <a:bodyPr wrap="square" rtlCol="0" anchor="ctr"/>
           <a:lstStyle/>
           <a:p>
-            <a:pPr algn="r" indent="0" marL="0">
+            <a:pPr marL="0" indent="0" algn="r">
               <a:buNone/>
             </a:pPr>
             <a:r>
@@ -9588,6 +9318,7 @@
         <a:solidFill>
           <a:srgbClr val="FFFFFF"/>
         </a:solidFill>
+        <a:effectLst/>
       </p:bgPr>
     </p:bg>
     <p:spTree>
@@ -9625,11 +9356,11 @@
           <a:bodyPr wrap="square" rtlCol="0" anchor="ctr"/>
           <a:lstStyle/>
           <a:p>
-            <a:pPr indent="0" marL="0">
-              <a:buNone/>
-            </a:pPr>
-            <a:r>
-              <a:rPr lang="en-US" sz="1200" b="1" spc="200" kern="0" dirty="0">
+            <a:pPr marL="0" indent="0">
+              <a:buNone/>
+            </a:pPr>
+            <a:r>
+              <a:rPr lang="en-US" sz="1200" b="1" kern="0" spc="200" dirty="0">
                 <a:solidFill>
                   <a:srgbClr val="1C7293"/>
                 </a:solidFill>
@@ -9664,7 +9395,7 @@
           <a:bodyPr wrap="square" rtlCol="0" anchor="ctr"/>
           <a:lstStyle/>
           <a:p>
-            <a:pPr algn="l" indent="0" marL="0">
+            <a:pPr marL="0" indent="0" algn="l">
               <a:buNone/>
             </a:pPr>
             <a:r>
@@ -9723,7 +9454,7 @@
           <a:bodyPr wrap="square" rtlCol="0" anchor="ctr"/>
           <a:lstStyle/>
           <a:p>
-            <a:pPr algn="ctr" indent="0" marL="0">
+            <a:pPr marL="0" indent="0" algn="ctr">
               <a:buNone/>
             </a:pPr>
             <a:r>
@@ -9762,7 +9493,7 @@
           <a:bodyPr wrap="square" rtlCol="0" anchor="ctr"/>
           <a:lstStyle/>
           <a:p>
-            <a:pPr algn="ctr" indent="0" marL="0">
+            <a:pPr marL="0" indent="0" algn="ctr">
               <a:buNone/>
             </a:pPr>
             <a:r>
@@ -9779,7 +9510,7 @@
             <a:endParaRPr lang="en-US" sz="1050" dirty="0"/>
           </a:p>
           <a:p>
-            <a:pPr algn="ctr" indent="0" marL="0">
+            <a:pPr marL="0" indent="0" algn="ctr">
               <a:buNone/>
             </a:pPr>
             <a:r>
@@ -9858,7 +9589,7 @@
           <a:bodyPr wrap="square" rtlCol="0" anchor="ctr"/>
           <a:lstStyle/>
           <a:p>
-            <a:pPr algn="ctr" indent="0" marL="0">
+            <a:pPr marL="0" indent="0" algn="ctr">
               <a:buNone/>
             </a:pPr>
             <a:r>
@@ -9897,7 +9628,7 @@
           <a:bodyPr wrap="square" rtlCol="0" anchor="ctr"/>
           <a:lstStyle/>
           <a:p>
-            <a:pPr algn="ctr" indent="0" marL="0">
+            <a:pPr marL="0" indent="0" algn="ctr">
               <a:buNone/>
             </a:pPr>
             <a:r>
@@ -9914,7 +9645,7 @@
             <a:endParaRPr lang="en-US" sz="1050" dirty="0"/>
           </a:p>
           <a:p>
-            <a:pPr algn="ctr" indent="0" marL="0">
+            <a:pPr marL="0" indent="0" algn="ctr">
               <a:buNone/>
             </a:pPr>
             <a:r>
@@ -9993,7 +9724,7 @@
           <a:bodyPr wrap="square" rtlCol="0" anchor="ctr"/>
           <a:lstStyle/>
           <a:p>
-            <a:pPr algn="ctr" indent="0" marL="0">
+            <a:pPr marL="0" indent="0" algn="ctr">
               <a:buNone/>
             </a:pPr>
             <a:r>
@@ -10032,7 +9763,7 @@
           <a:bodyPr wrap="square" rtlCol="0" anchor="ctr"/>
           <a:lstStyle/>
           <a:p>
-            <a:pPr algn="ctr" indent="0" marL="0">
+            <a:pPr marL="0" indent="0" algn="ctr">
               <a:buNone/>
             </a:pPr>
             <a:r>
@@ -10049,7 +9780,7 @@
             <a:endParaRPr lang="en-US" sz="1050" dirty="0"/>
           </a:p>
           <a:p>
-            <a:pPr algn="ctr" indent="0" marL="0">
+            <a:pPr marL="0" indent="0" algn="ctr">
               <a:buNone/>
             </a:pPr>
             <a:r>
@@ -10128,7 +9859,7 @@
           <a:bodyPr wrap="square" rtlCol="0" anchor="ctr"/>
           <a:lstStyle/>
           <a:p>
-            <a:pPr algn="ctr" indent="0" marL="0">
+            <a:pPr marL="0" indent="0" algn="ctr">
               <a:buNone/>
             </a:pPr>
             <a:r>
@@ -10167,7 +9898,7 @@
           <a:bodyPr wrap="square" rtlCol="0" anchor="ctr"/>
           <a:lstStyle/>
           <a:p>
-            <a:pPr algn="ctr" indent="0" marL="0">
+            <a:pPr marL="0" indent="0" algn="ctr">
               <a:buNone/>
             </a:pPr>
             <a:r>
@@ -10184,7 +9915,7 @@
             <a:endParaRPr lang="en-US" sz="1050" dirty="0"/>
           </a:p>
           <a:p>
-            <a:pPr algn="ctr" indent="0" marL="0">
+            <a:pPr marL="0" indent="0" algn="ctr">
               <a:buNone/>
             </a:pPr>
             <a:r>
@@ -10263,7 +9994,7 @@
           <a:bodyPr wrap="square" rtlCol="0" anchor="ctr"/>
           <a:lstStyle/>
           <a:p>
-            <a:pPr algn="ctr" indent="0" marL="0">
+            <a:pPr marL="0" indent="0" algn="ctr">
               <a:buNone/>
             </a:pPr>
             <a:r>
@@ -10302,7 +10033,7 @@
           <a:bodyPr wrap="square" rtlCol="0" anchor="ctr"/>
           <a:lstStyle/>
           <a:p>
-            <a:pPr algn="ctr" indent="0" marL="0">
+            <a:pPr marL="0" indent="0" algn="ctr">
               <a:buNone/>
             </a:pPr>
             <a:r>
@@ -10319,7 +10050,7 @@
             <a:endParaRPr lang="en-US" sz="1050" dirty="0"/>
           </a:p>
           <a:p>
-            <a:pPr algn="ctr" indent="0" marL="0">
+            <a:pPr marL="0" indent="0" algn="ctr">
               <a:buNone/>
             </a:pPr>
             <a:r>
@@ -10398,7 +10129,7 @@
           <a:bodyPr wrap="square" rtlCol="0" anchor="ctr"/>
           <a:lstStyle/>
           <a:p>
-            <a:pPr algn="ctr" indent="0" marL="0">
+            <a:pPr marL="0" indent="0" algn="ctr">
               <a:buNone/>
             </a:pPr>
             <a:r>
@@ -10437,7 +10168,7 @@
           <a:bodyPr wrap="square" rtlCol="0" anchor="ctr"/>
           <a:lstStyle/>
           <a:p>
-            <a:pPr algn="ctr" indent="0" marL="0">
+            <a:pPr marL="0" indent="0" algn="ctr">
               <a:buNone/>
             </a:pPr>
             <a:r>
@@ -10454,7 +10185,7 @@
             <a:endParaRPr lang="en-US" sz="1050" dirty="0"/>
           </a:p>
           <a:p>
-            <a:pPr algn="ctr" indent="0" marL="0">
+            <a:pPr marL="0" indent="0" algn="ctr">
               <a:buNone/>
             </a:pPr>
             <a:r>
@@ -10493,7 +10224,7 @@
           <a:bodyPr wrap="square" rtlCol="0" anchor="ctr"/>
           <a:lstStyle/>
           <a:p>
-            <a:pPr algn="ctr" indent="0" marL="0">
+            <a:pPr marL="0" indent="0" algn="ctr">
               <a:buNone/>
             </a:pPr>
             <a:r>
@@ -10532,7 +10263,7 @@
           <a:bodyPr wrap="square" rtlCol="0" anchor="ctr"/>
           <a:lstStyle/>
           <a:p>
-            <a:pPr indent="0" marL="0">
+            <a:pPr marL="0" indent="0">
               <a:buNone/>
             </a:pPr>
             <a:r>
@@ -10571,7 +10302,7 @@
           <a:bodyPr wrap="square" rtlCol="0" anchor="ctr"/>
           <a:lstStyle/>
           <a:p>
-            <a:pPr algn="l" indent="0" marL="0">
+            <a:pPr marL="0" indent="0" algn="l">
               <a:buNone/>
             </a:pPr>
             <a:r>
@@ -10610,7 +10341,7 @@
           <a:bodyPr wrap="square" rtlCol="0" anchor="ctr"/>
           <a:lstStyle/>
           <a:p>
-            <a:pPr indent="0" marL="0">
+            <a:pPr marL="0" indent="0">
               <a:buNone/>
             </a:pPr>
             <a:r>
@@ -10649,7 +10380,7 @@
           <a:bodyPr wrap="square" rtlCol="0" anchor="ctr"/>
           <a:lstStyle/>
           <a:p>
-            <a:pPr algn="r" indent="0" marL="0">
+            <a:pPr marL="0" indent="0" algn="r">
               <a:buNone/>
             </a:pPr>
             <a:r>
@@ -10683,6 +10414,7 @@
         <a:solidFill>
           <a:srgbClr val="FFFFFF"/>
         </a:solidFill>
+        <a:effectLst/>
       </p:bgPr>
     </p:bg>
     <p:spTree>
@@ -10720,11 +10452,11 @@
           <a:bodyPr wrap="square" rtlCol="0" anchor="ctr"/>
           <a:lstStyle/>
           <a:p>
-            <a:pPr indent="0" marL="0">
-              <a:buNone/>
-            </a:pPr>
-            <a:r>
-              <a:rPr lang="en-US" sz="1200" b="1" spc="200" kern="0" dirty="0">
+            <a:pPr marL="0" indent="0">
+              <a:buNone/>
+            </a:pPr>
+            <a:r>
+              <a:rPr lang="en-US" sz="1200" b="1" kern="0" spc="200" dirty="0">
                 <a:solidFill>
                   <a:srgbClr val="1C7293"/>
                 </a:solidFill>
@@ -10759,7 +10491,7 @@
           <a:bodyPr wrap="square" rtlCol="0" anchor="ctr"/>
           <a:lstStyle/>
           <a:p>
-            <a:pPr algn="l" indent="0" marL="0">
+            <a:pPr marL="0" indent="0" algn="l">
               <a:buNone/>
             </a:pPr>
             <a:r>
@@ -10818,7 +10550,7 @@
           <a:bodyPr wrap="square" rtlCol="0" anchor="ctr"/>
           <a:lstStyle/>
           <a:p>
-            <a:pPr indent="0" marL="0">
+            <a:pPr marL="0" indent="0">
               <a:buNone/>
             </a:pPr>
             <a:r>
@@ -10857,7 +10589,7 @@
           <a:bodyPr wrap="square" rtlCol="0" anchor="ctr"/>
           <a:lstStyle/>
           <a:p>
-            <a:pPr indent="0" marL="0">
+            <a:pPr marL="0" indent="0">
               <a:lnSpc>
                 <a:spcPct val="115000"/>
               </a:lnSpc>
@@ -10922,7 +10654,7 @@
           <a:bodyPr wrap="square" rtlCol="0" anchor="ctr"/>
           <a:lstStyle/>
           <a:p>
-            <a:pPr indent="0" marL="0">
+            <a:pPr marL="0" indent="0">
               <a:buNone/>
             </a:pPr>
             <a:r>
@@ -10961,7 +10693,7 @@
           <a:bodyPr wrap="square" rtlCol="0" anchor="ctr"/>
           <a:lstStyle/>
           <a:p>
-            <a:pPr indent="0" marL="0">
+            <a:pPr marL="0" indent="0">
               <a:buNone/>
             </a:pPr>
             <a:r>
@@ -11020,7 +10752,7 @@
           <a:bodyPr wrap="square" rtlCol="0" anchor="ctr"/>
           <a:lstStyle/>
           <a:p>
-            <a:pPr indent="0" marL="0">
+            <a:pPr marL="0" indent="0">
               <a:buNone/>
             </a:pPr>
             <a:r>
@@ -11059,7 +10791,7 @@
           <a:bodyPr wrap="square" rtlCol="0" anchor="ctr"/>
           <a:lstStyle/>
           <a:p>
-            <a:pPr indent="0" marL="0">
+            <a:pPr marL="0" indent="0">
               <a:lnSpc>
                 <a:spcPct val="115000"/>
               </a:lnSpc>
@@ -11124,7 +10856,7 @@
           <a:bodyPr wrap="square" rtlCol="0" anchor="ctr"/>
           <a:lstStyle/>
           <a:p>
-            <a:pPr indent="0" marL="0">
+            <a:pPr marL="0" indent="0">
               <a:buNone/>
             </a:pPr>
             <a:r>
@@ -11163,7 +10895,7 @@
           <a:bodyPr wrap="square" rtlCol="0" anchor="ctr"/>
           <a:lstStyle/>
           <a:p>
-            <a:pPr indent="0" marL="0">
+            <a:pPr marL="0" indent="0">
               <a:buNone/>
             </a:pPr>
             <a:r>
@@ -11202,7 +10934,7 @@
           <a:bodyPr wrap="square" rtlCol="0" anchor="ctr"/>
           <a:lstStyle/>
           <a:p>
-            <a:pPr indent="0" marL="0">
+            <a:pPr marL="0" indent="0">
               <a:buNone/>
             </a:pPr>
             <a:r>
@@ -11241,7 +10973,7 @@
           <a:bodyPr wrap="square" rtlCol="0" anchor="ctr"/>
           <a:lstStyle/>
           <a:p>
-            <a:pPr algn="r" indent="0" marL="0">
+            <a:pPr marL="0" indent="0" algn="r">
               <a:buNone/>
             </a:pPr>
             <a:r>
@@ -11275,6 +11007,7 @@
         <a:solidFill>
           <a:srgbClr val="FFFFFF"/>
         </a:solidFill>
+        <a:effectLst/>
       </p:bgPr>
     </p:bg>
     <p:spTree>
@@ -11312,11 +11045,11 @@
           <a:bodyPr wrap="square" rtlCol="0" anchor="ctr"/>
           <a:lstStyle/>
           <a:p>
-            <a:pPr indent="0" marL="0">
-              <a:buNone/>
-            </a:pPr>
-            <a:r>
-              <a:rPr lang="en-US" sz="1200" b="1" spc="200" kern="0" dirty="0">
+            <a:pPr marL="0" indent="0">
+              <a:buNone/>
+            </a:pPr>
+            <a:r>
+              <a:rPr lang="en-US" sz="1200" b="1" kern="0" spc="200" dirty="0">
                 <a:solidFill>
                   <a:srgbClr val="1C7293"/>
                 </a:solidFill>
@@ -11351,7 +11084,7 @@
           <a:bodyPr wrap="square" rtlCol="0" anchor="ctr"/>
           <a:lstStyle/>
           <a:p>
-            <a:pPr algn="l" indent="0" marL="0">
+            <a:pPr marL="0" indent="0" algn="l">
               <a:buNone/>
             </a:pPr>
             <a:r>
@@ -11410,7 +11143,7 @@
           <a:bodyPr wrap="square" rtlCol="0" anchor="ctr"/>
           <a:lstStyle/>
           <a:p>
-            <a:pPr algn="ctr" indent="0" marL="0">
+            <a:pPr marL="0" indent="0" algn="ctr">
               <a:buNone/>
             </a:pPr>
             <a:r>
@@ -11449,7 +11182,7 @@
           <a:bodyPr wrap="square" rtlCol="0" anchor="ctr"/>
           <a:lstStyle/>
           <a:p>
-            <a:pPr indent="0" marL="0">
+            <a:pPr marL="0" indent="0">
               <a:buNone/>
             </a:pPr>
             <a:r>
@@ -11488,7 +11221,7 @@
           <a:bodyPr wrap="square" rtlCol="0" anchor="ctr"/>
           <a:lstStyle/>
           <a:p>
-            <a:pPr indent="0" marL="0">
+            <a:pPr marL="0" indent="0">
               <a:buNone/>
             </a:pPr>
             <a:r>
@@ -11547,7 +11280,7 @@
           <a:bodyPr wrap="square" rtlCol="0" anchor="ctr"/>
           <a:lstStyle/>
           <a:p>
-            <a:pPr algn="ctr" indent="0" marL="0">
+            <a:pPr marL="0" indent="0" algn="ctr">
               <a:buNone/>
             </a:pPr>
             <a:r>
@@ -11586,7 +11319,7 @@
           <a:bodyPr wrap="square" rtlCol="0" anchor="ctr"/>
           <a:lstStyle/>
           <a:p>
-            <a:pPr indent="0" marL="0">
+            <a:pPr marL="0" indent="0">
               <a:buNone/>
             </a:pPr>
             <a:r>
@@ -11625,7 +11358,7 @@
           <a:bodyPr wrap="square" rtlCol="0" anchor="ctr"/>
           <a:lstStyle/>
           <a:p>
-            <a:pPr indent="0" marL="0">
+            <a:pPr marL="0" indent="0">
               <a:buNone/>
             </a:pPr>
             <a:r>
@@ -11684,7 +11417,7 @@
           <a:bodyPr wrap="square" rtlCol="0" anchor="ctr"/>
           <a:lstStyle/>
           <a:p>
-            <a:pPr algn="ctr" indent="0" marL="0">
+            <a:pPr marL="0" indent="0" algn="ctr">
               <a:buNone/>
             </a:pPr>
             <a:r>
@@ -11723,7 +11456,7 @@
           <a:bodyPr wrap="square" rtlCol="0" anchor="ctr"/>
           <a:lstStyle/>
           <a:p>
-            <a:pPr indent="0" marL="0">
+            <a:pPr marL="0" indent="0">
               <a:buNone/>
             </a:pPr>
             <a:r>
@@ -11762,7 +11495,7 @@
           <a:bodyPr wrap="square" rtlCol="0" anchor="ctr"/>
           <a:lstStyle/>
           <a:p>
-            <a:pPr indent="0" marL="0">
+            <a:pPr marL="0" indent="0">
               <a:buNone/>
             </a:pPr>
             <a:r>
@@ -11801,7 +11534,7 @@
           <a:bodyPr wrap="square" rtlCol="0" anchor="ctr"/>
           <a:lstStyle/>
           <a:p>
-            <a:pPr indent="0" marL="0">
+            <a:pPr marL="0" indent="0">
               <a:buNone/>
             </a:pPr>
             <a:r>
@@ -11840,7 +11573,7 @@
           <a:bodyPr wrap="square" rtlCol="0" anchor="ctr"/>
           <a:lstStyle/>
           <a:p>
-            <a:pPr algn="r" indent="0" marL="0">
+            <a:pPr marL="0" indent="0" algn="r">
               <a:buNone/>
             </a:pPr>
             <a:r>
@@ -11874,6 +11607,7 @@
         <a:solidFill>
           <a:srgbClr val="FFFFFF"/>
         </a:solidFill>
+        <a:effectLst/>
       </p:bgPr>
     </p:bg>
     <p:spTree>
@@ -11911,11 +11645,11 @@
           <a:bodyPr wrap="square" rtlCol="0" anchor="ctr"/>
           <a:lstStyle/>
           <a:p>
-            <a:pPr indent="0" marL="0">
-              <a:buNone/>
-            </a:pPr>
-            <a:r>
-              <a:rPr lang="en-US" sz="1200" b="1" spc="200" kern="0" dirty="0">
+            <a:pPr marL="0" indent="0">
+              <a:buNone/>
+            </a:pPr>
+            <a:r>
+              <a:rPr lang="en-US" sz="1200" b="1" kern="0" spc="200" dirty="0">
                 <a:solidFill>
                   <a:srgbClr val="1C7293"/>
                 </a:solidFill>
@@ -11950,7 +11684,7 @@
           <a:bodyPr wrap="square" rtlCol="0" anchor="ctr"/>
           <a:lstStyle/>
           <a:p>
-            <a:pPr algn="l" indent="0" marL="0">
+            <a:pPr marL="0" indent="0" algn="l">
               <a:buNone/>
             </a:pPr>
             <a:r>
@@ -11970,7 +11704,7 @@
       </p:sp>
       <p:graphicFrame>
         <p:nvGraphicFramePr>
-          <p:cNvPr id="4" name="Chart 0" descr=""/>
+          <p:cNvPr id="4" name="Chart 0"/>
           <p:cNvGraphicFramePr/>
           <p:nvPr/>
         </p:nvGraphicFramePr>
@@ -11978,9 +11712,9 @@
           <a:off x="548640" y="1783080"/>
           <a:ext cx="6949440" cy="4206240"/>
         </p:xfrm>
-        <a:graphic xmlns:a="http://schemas.openxmlformats.org/drawingml/2006/main">
+        <a:graphic>
           <a:graphicData uri="http://schemas.openxmlformats.org/drawingml/2006/chart">
-            <c:chart xmlns:c="http://schemas.openxmlformats.org/drawingml/2006/chart" r:id="rId1"/>
+            <c:chart xmlns:c="http://schemas.openxmlformats.org/drawingml/2006/chart" xmlns:r="http://schemas.openxmlformats.org/officeDocument/2006/relationships" r:id="rId3"/>
           </a:graphicData>
         </a:graphic>
       </p:graphicFrame>
@@ -12005,7 +11739,7 @@
           <a:bodyPr wrap="square" rtlCol="0" anchor="ctr"/>
           <a:lstStyle/>
           <a:p>
-            <a:pPr indent="0" marL="0">
+            <a:pPr marL="0" indent="0">
               <a:buNone/>
             </a:pPr>
             <a:r>
@@ -12044,7 +11778,7 @@
           <a:bodyPr wrap="square" rtlCol="0" anchor="ctr"/>
           <a:lstStyle/>
           <a:p>
-            <a:pPr indent="0" marL="0">
+            <a:pPr marL="0" indent="0">
               <a:buNone/>
             </a:pPr>
             <a:r>
@@ -12083,7 +11817,7 @@
           <a:bodyPr wrap="square" rtlCol="0" anchor="ctr"/>
           <a:lstStyle/>
           <a:p>
-            <a:pPr indent="0" marL="0">
+            <a:pPr marL="0" indent="0">
               <a:buNone/>
             </a:pPr>
             <a:r>
@@ -12122,7 +11856,7 @@
           <a:bodyPr wrap="square" rtlCol="0" anchor="ctr"/>
           <a:lstStyle/>
           <a:p>
-            <a:pPr indent="0" marL="0">
+            <a:pPr marL="0" indent="0">
               <a:buNone/>
             </a:pPr>
             <a:r>
@@ -12161,7 +11895,7 @@
           <a:bodyPr wrap="square" rtlCol="0" anchor="ctr"/>
           <a:lstStyle/>
           <a:p>
-            <a:pPr indent="0" marL="0">
+            <a:pPr marL="0" indent="0">
               <a:buNone/>
             </a:pPr>
             <a:r>
@@ -12200,7 +11934,7 @@
           <a:bodyPr wrap="square" rtlCol="0" anchor="ctr"/>
           <a:lstStyle/>
           <a:p>
-            <a:pPr indent="0" marL="0">
+            <a:pPr marL="0" indent="0">
               <a:buNone/>
             </a:pPr>
             <a:r>
@@ -12239,7 +11973,7 @@
           <a:bodyPr wrap="square" rtlCol="0" anchor="ctr"/>
           <a:lstStyle/>
           <a:p>
-            <a:pPr indent="0" marL="0">
+            <a:pPr marL="0" indent="0">
               <a:buNone/>
             </a:pPr>
             <a:r>
@@ -12278,7 +12012,7 @@
           <a:bodyPr wrap="square" rtlCol="0" anchor="ctr"/>
           <a:lstStyle/>
           <a:p>
-            <a:pPr algn="r" indent="0" marL="0">
+            <a:pPr marL="0" indent="0" algn="r">
               <a:buNone/>
             </a:pPr>
             <a:r>
@@ -12312,6 +12046,7 @@
         <a:solidFill>
           <a:srgbClr val="FFFFFF"/>
         </a:solidFill>
+        <a:effectLst/>
       </p:bgPr>
     </p:bg>
     <p:spTree>
@@ -12349,11 +12084,11 @@
           <a:bodyPr wrap="square" rtlCol="0" anchor="ctr"/>
           <a:lstStyle/>
           <a:p>
-            <a:pPr indent="0" marL="0">
-              <a:buNone/>
-            </a:pPr>
-            <a:r>
-              <a:rPr lang="en-US" sz="1200" b="1" spc="200" kern="0" dirty="0">
+            <a:pPr marL="0" indent="0">
+              <a:buNone/>
+            </a:pPr>
+            <a:r>
+              <a:rPr lang="en-US" sz="1200" b="1" kern="0" spc="200" dirty="0">
                 <a:solidFill>
                   <a:srgbClr val="1C7293"/>
                 </a:solidFill>
@@ -12388,7 +12123,7 @@
           <a:bodyPr wrap="square" rtlCol="0" anchor="ctr"/>
           <a:lstStyle/>
           <a:p>
-            <a:pPr algn="l" indent="0" marL="0">
+            <a:pPr marL="0" indent="0" algn="l">
               <a:buNone/>
             </a:pPr>
             <a:r>
@@ -12467,7 +12202,7 @@
           <a:bodyPr wrap="square" rtlCol="0" anchor="ctr"/>
           <a:lstStyle/>
           <a:p>
-            <a:pPr algn="ctr" indent="0" marL="0">
+            <a:pPr marL="0" indent="0" algn="ctr">
               <a:buNone/>
             </a:pPr>
             <a:r>
@@ -12506,7 +12241,7 @@
           <a:bodyPr wrap="square" rtlCol="0" anchor="ctr"/>
           <a:lstStyle/>
           <a:p>
-            <a:pPr indent="0" marL="0">
+            <a:pPr marL="0" indent="0">
               <a:lnSpc>
                 <a:spcPct val="110000"/>
               </a:lnSpc>
@@ -12588,7 +12323,7 @@
           <a:bodyPr wrap="square" rtlCol="0" anchor="ctr"/>
           <a:lstStyle/>
           <a:p>
-            <a:pPr algn="ctr" indent="0" marL="0">
+            <a:pPr marL="0" indent="0" algn="ctr">
               <a:buNone/>
             </a:pPr>
             <a:r>
@@ -12627,7 +12362,7 @@
           <a:bodyPr wrap="square" rtlCol="0" anchor="ctr"/>
           <a:lstStyle/>
           <a:p>
-            <a:pPr indent="0" marL="0">
+            <a:pPr marL="0" indent="0">
               <a:lnSpc>
                 <a:spcPct val="110000"/>
               </a:lnSpc>
@@ -12709,7 +12444,7 @@
           <a:bodyPr wrap="square" rtlCol="0" anchor="ctr"/>
           <a:lstStyle/>
           <a:p>
-            <a:pPr algn="ctr" indent="0" marL="0">
+            <a:pPr marL="0" indent="0" algn="ctr">
               <a:buNone/>
             </a:pPr>
             <a:r>
@@ -12748,7 +12483,7 @@
           <a:bodyPr wrap="square" rtlCol="0" anchor="ctr"/>
           <a:lstStyle/>
           <a:p>
-            <a:pPr indent="0" marL="0">
+            <a:pPr marL="0" indent="0">
               <a:lnSpc>
                 <a:spcPct val="110000"/>
               </a:lnSpc>
@@ -12830,7 +12565,7 @@
           <a:bodyPr wrap="square" rtlCol="0" anchor="ctr"/>
           <a:lstStyle/>
           <a:p>
-            <a:pPr algn="ctr" indent="0" marL="0">
+            <a:pPr marL="0" indent="0" algn="ctr">
               <a:buNone/>
             </a:pPr>
             <a:r>
@@ -12869,7 +12604,7 @@
           <a:bodyPr wrap="square" rtlCol="0" anchor="ctr"/>
           <a:lstStyle/>
           <a:p>
-            <a:pPr indent="0" marL="0">
+            <a:pPr marL="0" indent="0">
               <a:lnSpc>
                 <a:spcPct val="110000"/>
               </a:lnSpc>
@@ -12911,7 +12646,7 @@
           <a:bodyPr wrap="square" rtlCol="0" anchor="ctr"/>
           <a:lstStyle/>
           <a:p>
-            <a:pPr indent="0" marL="0">
+            <a:pPr marL="0" indent="0">
               <a:buNone/>
             </a:pPr>
             <a:r>
@@ -12950,7 +12685,7 @@
           <a:bodyPr wrap="square" rtlCol="0" anchor="ctr"/>
           <a:lstStyle/>
           <a:p>
-            <a:pPr algn="r" indent="0" marL="0">
+            <a:pPr marL="0" indent="0" algn="r">
               <a:buNone/>
             </a:pPr>
             <a:r>
@@ -12984,6 +12719,7 @@
         <a:solidFill>
           <a:srgbClr val="FFFFFF"/>
         </a:solidFill>
+        <a:effectLst/>
       </p:bgPr>
     </p:bg>
     <p:spTree>
@@ -13021,11 +12757,11 @@
           <a:bodyPr wrap="square" rtlCol="0" anchor="ctr"/>
           <a:lstStyle/>
           <a:p>
-            <a:pPr indent="0" marL="0">
-              <a:buNone/>
-            </a:pPr>
-            <a:r>
-              <a:rPr lang="en-US" sz="1200" b="1" spc="200" kern="0" dirty="0">
+            <a:pPr marL="0" indent="0">
+              <a:buNone/>
+            </a:pPr>
+            <a:r>
+              <a:rPr lang="en-US" sz="1200" b="1" kern="0" spc="200" dirty="0">
                 <a:solidFill>
                   <a:srgbClr val="1C7293"/>
                 </a:solidFill>
@@ -13060,7 +12796,7 @@
           <a:bodyPr wrap="square" rtlCol="0" anchor="ctr"/>
           <a:lstStyle/>
           <a:p>
-            <a:pPr algn="l" indent="0" marL="0">
+            <a:pPr marL="0" indent="0" algn="l">
               <a:buNone/>
             </a:pPr>
             <a:r>
@@ -13119,7 +12855,7 @@
           <a:bodyPr wrap="square" rtlCol="0" anchor="ctr"/>
           <a:lstStyle/>
           <a:p>
-            <a:pPr algn="ctr" indent="0" marL="0">
+            <a:pPr marL="0" indent="0" algn="ctr">
               <a:buNone/>
             </a:pPr>
             <a:r>
@@ -13158,7 +12894,7 @@
           <a:bodyPr wrap="square" rtlCol="0" anchor="ctr"/>
           <a:lstStyle/>
           <a:p>
-            <a:pPr algn="ctr" indent="0" marL="0">
+            <a:pPr marL="0" indent="0" algn="ctr">
               <a:buNone/>
             </a:pPr>
             <a:r>
@@ -13197,7 +12933,7 @@
           <a:bodyPr wrap="square" rtlCol="0" anchor="ctr"/>
           <a:lstStyle/>
           <a:p>
-            <a:pPr algn="ctr" indent="0" marL="0">
+            <a:pPr marL="0" indent="0" algn="ctr">
               <a:buNone/>
             </a:pPr>
             <a:r>
@@ -13261,7 +12997,7 @@
           <a:bodyPr wrap="square" rtlCol="0" anchor="ctr"/>
           <a:lstStyle/>
           <a:p>
-            <a:pPr algn="ctr" indent="0" marL="0">
+            <a:pPr marL="0" indent="0" algn="ctr">
               <a:buNone/>
             </a:pPr>
             <a:r>
@@ -13300,7 +13036,7 @@
           <a:bodyPr wrap="square" rtlCol="0" anchor="ctr"/>
           <a:lstStyle/>
           <a:p>
-            <a:pPr algn="ctr" indent="0" marL="0">
+            <a:pPr marL="0" indent="0" algn="ctr">
               <a:buNone/>
             </a:pPr>
             <a:r>
@@ -13364,7 +13100,7 @@
           <a:bodyPr wrap="square" rtlCol="0" anchor="ctr"/>
           <a:lstStyle/>
           <a:p>
-            <a:pPr algn="ctr" indent="0" marL="0">
+            <a:pPr marL="0" indent="0" algn="ctr">
               <a:buNone/>
             </a:pPr>
             <a:r>
@@ -13403,7 +13139,7 @@
           <a:bodyPr wrap="square" rtlCol="0" anchor="ctr"/>
           <a:lstStyle/>
           <a:p>
-            <a:pPr algn="ctr" indent="0" marL="0">
+            <a:pPr marL="0" indent="0" algn="ctr">
               <a:buNone/>
             </a:pPr>
             <a:r>
@@ -13467,7 +13203,7 @@
           <a:bodyPr wrap="square" rtlCol="0" anchor="ctr"/>
           <a:lstStyle/>
           <a:p>
-            <a:pPr algn="ctr" indent="0" marL="0">
+            <a:pPr marL="0" indent="0" algn="ctr">
               <a:buNone/>
             </a:pPr>
             <a:r>
@@ -13506,7 +13242,7 @@
           <a:bodyPr wrap="square" rtlCol="0" anchor="ctr"/>
           <a:lstStyle/>
           <a:p>
-            <a:pPr algn="ctr" indent="0" marL="0">
+            <a:pPr marL="0" indent="0" algn="ctr">
               <a:buNone/>
             </a:pPr>
             <a:r>
@@ -13570,7 +13306,7 @@
           <a:bodyPr wrap="square" rtlCol="0" anchor="ctr"/>
           <a:lstStyle/>
           <a:p>
-            <a:pPr algn="ctr" indent="0" marL="0">
+            <a:pPr marL="0" indent="0" algn="ctr">
               <a:buNone/>
             </a:pPr>
             <a:r>
@@ -13609,7 +13345,7 @@
           <a:bodyPr wrap="square" rtlCol="0" anchor="ctr"/>
           <a:lstStyle/>
           <a:p>
-            <a:pPr algn="ctr" indent="0" marL="0">
+            <a:pPr marL="0" indent="0" algn="ctr">
               <a:buNone/>
             </a:pPr>
             <a:r>
@@ -13673,7 +13409,7 @@
           <a:bodyPr wrap="square" rtlCol="0" anchor="ctr"/>
           <a:lstStyle/>
           <a:p>
-            <a:pPr algn="ctr" indent="0" marL="0">
+            <a:pPr marL="0" indent="0" algn="ctr">
               <a:buNone/>
             </a:pPr>
             <a:r>
@@ -13712,7 +13448,7 @@
           <a:bodyPr wrap="square" rtlCol="0" anchor="ctr"/>
           <a:lstStyle/>
           <a:p>
-            <a:pPr algn="ctr" indent="0" marL="0">
+            <a:pPr marL="0" indent="0" algn="ctr">
               <a:buNone/>
             </a:pPr>
             <a:r>
@@ -13751,7 +13487,7 @@
           <a:bodyPr wrap="square" rtlCol="0" anchor="ctr"/>
           <a:lstStyle/>
           <a:p>
-            <a:pPr indent="0" marL="0">
+            <a:pPr marL="0" indent="0">
               <a:buNone/>
             </a:pPr>
             <a:r>
@@ -13790,7 +13526,7 @@
           <a:bodyPr wrap="square" rtlCol="0" anchor="ctr"/>
           <a:lstStyle/>
           <a:p>
-            <a:pPr algn="r" indent="0" marL="0">
+            <a:pPr marL="0" indent="0" algn="r">
               <a:buNone/>
             </a:pPr>
             <a:r>
@@ -14109,4 +13845,299 @@
     </a:ext>
   </a:extLst>
 </a:theme>
+</file>
+
+<file path=ppt/theme/theme2.xml><?xml version="1.0" encoding="utf-8"?>
+<a:theme xmlns:a="http://schemas.openxmlformats.org/drawingml/2006/main" name="Tema do Office">
+  <a:themeElements>
+    <a:clrScheme name="Office">
+      <a:dk1>
+        <a:sysClr val="windowText" lastClr="000000"/>
+      </a:dk1>
+      <a:lt1>
+        <a:sysClr val="window" lastClr="FFFFFF"/>
+      </a:lt1>
+      <a:dk2>
+        <a:srgbClr val="44546A"/>
+      </a:dk2>
+      <a:lt2>
+        <a:srgbClr val="E7E6E6"/>
+      </a:lt2>
+      <a:accent1>
+        <a:srgbClr val="4472C4"/>
+      </a:accent1>
+      <a:accent2>
+        <a:srgbClr val="ED7D31"/>
+      </a:accent2>
+      <a:accent3>
+        <a:srgbClr val="A5A5A5"/>
+      </a:accent3>
+      <a:accent4>
+        <a:srgbClr val="FFC000"/>
+      </a:accent4>
+      <a:accent5>
+        <a:srgbClr val="5B9BD5"/>
+      </a:accent5>
+      <a:accent6>
+        <a:srgbClr val="70AD47"/>
+      </a:accent6>
+      <a:hlink>
+        <a:srgbClr val="0563C1"/>
+      </a:hlink>
+      <a:folHlink>
+        <a:srgbClr val="954F72"/>
+      </a:folHlink>
+    </a:clrScheme>
+    <a:fontScheme name="Office">
+      <a:majorFont>
+        <a:latin typeface="Calibri Light" panose="020F0302020204030204"/>
+        <a:ea typeface=""/>
+        <a:cs typeface=""/>
+        <a:font script="Jpan" typeface="游ゴシック Light"/>
+        <a:font script="Hang" typeface="맑은 고딕"/>
+        <a:font script="Hans" typeface="等线 Light"/>
+        <a:font script="Hant" typeface="新細明體"/>
+        <a:font script="Arab" typeface="Times New Roman"/>
+        <a:font script="Hebr" typeface="Times New Roman"/>
+        <a:font script="Thai" typeface="Angsana New"/>
+        <a:font script="Ethi" typeface="Nyala"/>
+        <a:font script="Beng" typeface="Vrinda"/>
+        <a:font script="Gujr" typeface="Shruti"/>
+        <a:font script="Khmr" typeface="MoolBoran"/>
+        <a:font script="Knda" typeface="Tunga"/>
+        <a:font script="Guru" typeface="Raavi"/>
+        <a:font script="Cans" typeface="Euphemia"/>
+        <a:font script="Cher" typeface="Plantagenet Cherokee"/>
+        <a:font script="Yiii" typeface="Microsoft Yi Baiti"/>
+        <a:font script="Tibt" typeface="Microsoft Himalaya"/>
+        <a:font script="Thaa" typeface="MV Boli"/>
+        <a:font script="Deva" typeface="Mangal"/>
+        <a:font script="Telu" typeface="Gautami"/>
+        <a:font script="Taml" typeface="Latha"/>
+        <a:font script="Syrc" typeface="Estrangelo Edessa"/>
+        <a:font script="Orya" typeface="Kalinga"/>
+        <a:font script="Mlym" typeface="Kartika"/>
+        <a:font script="Laoo" typeface="DokChampa"/>
+        <a:font script="Sinh" typeface="Iskoola Pota"/>
+        <a:font script="Mong" typeface="Mongolian Baiti"/>
+        <a:font script="Viet" typeface="Times New Roman"/>
+        <a:font script="Uigh" typeface="Microsoft Uighur"/>
+        <a:font script="Geor" typeface="Sylfaen"/>
+        <a:font script="Armn" typeface="Arial"/>
+        <a:font script="Bugi" typeface="Leelawadee UI"/>
+        <a:font script="Bopo" typeface="Microsoft JhengHei"/>
+        <a:font script="Java" typeface="Javanese Text"/>
+        <a:font script="Lisu" typeface="Segoe UI"/>
+        <a:font script="Mymr" typeface="Myanmar Text"/>
+        <a:font script="Nkoo" typeface="Ebrima"/>
+        <a:font script="Olck" typeface="Nirmala UI"/>
+        <a:font script="Osma" typeface="Ebrima"/>
+        <a:font script="Phag" typeface="Phagspa"/>
+        <a:font script="Syrn" typeface="Estrangelo Edessa"/>
+        <a:font script="Syrj" typeface="Estrangelo Edessa"/>
+        <a:font script="Syre" typeface="Estrangelo Edessa"/>
+        <a:font script="Sora" typeface="Nirmala UI"/>
+        <a:font script="Tale" typeface="Microsoft Tai Le"/>
+        <a:font script="Talu" typeface="Microsoft New Tai Lue"/>
+        <a:font script="Tfng" typeface="Ebrima"/>
+      </a:majorFont>
+      <a:minorFont>
+        <a:latin typeface="Calibri" panose="020F0502020204030204"/>
+        <a:ea typeface=""/>
+        <a:cs typeface=""/>
+        <a:font script="Jpan" typeface="游ゴシック"/>
+        <a:font script="Hang" typeface="맑은 고딕"/>
+        <a:font script="Hans" typeface="等线"/>
+        <a:font script="Hant" typeface="新細明體"/>
+        <a:font script="Arab" typeface="Arial"/>
+        <a:font script="Hebr" typeface="Arial"/>
+        <a:font script="Thai" typeface="Cordia New"/>
+        <a:font script="Ethi" typeface="Nyala"/>
+        <a:font script="Beng" typeface="Vrinda"/>
+        <a:font script="Gujr" typeface="Shruti"/>
+        <a:font script="Khmr" typeface="DaunPenh"/>
+        <a:font script="Knda" typeface="Tunga"/>
+        <a:font script="Guru" typeface="Raavi"/>
+        <a:font script="Cans" typeface="Euphemia"/>
+        <a:font script="Cher" typeface="Plantagenet Cherokee"/>
+        <a:font script="Yiii" typeface="Microsoft Yi Baiti"/>
+        <a:font script="Tibt" typeface="Microsoft Himalaya"/>
+        <a:font script="Thaa" typeface="MV Boli"/>
+        <a:font script="Deva" typeface="Mangal"/>
+        <a:font script="Telu" typeface="Gautami"/>
+        <a:font script="Taml" typeface="Latha"/>
+        <a:font script="Syrc" typeface="Estrangelo Edessa"/>
+        <a:font script="Orya" typeface="Kalinga"/>
+        <a:font script="Mlym" typeface="Kartika"/>
+        <a:font script="Laoo" typeface="DokChampa"/>
+        <a:font script="Sinh" typeface="Iskoola Pota"/>
+        <a:font script="Mong" typeface="Mongolian Baiti"/>
+        <a:font script="Viet" typeface="Arial"/>
+        <a:font script="Uigh" typeface="Microsoft Uighur"/>
+        <a:font script="Geor" typeface="Sylfaen"/>
+        <a:font script="Armn" typeface="Arial"/>
+        <a:font script="Bugi" typeface="Leelawadee UI"/>
+        <a:font script="Bopo" typeface="Microsoft JhengHei"/>
+        <a:font script="Java" typeface="Javanese Text"/>
+        <a:font script="Lisu" typeface="Segoe UI"/>
+        <a:font script="Mymr" typeface="Myanmar Text"/>
+        <a:font script="Nkoo" typeface="Ebrima"/>
+        <a:font script="Olck" typeface="Nirmala UI"/>
+        <a:font script="Osma" typeface="Ebrima"/>
+        <a:font script="Phag" typeface="Phagspa"/>
+        <a:font script="Syrn" typeface="Estrangelo Edessa"/>
+        <a:font script="Syrj" typeface="Estrangelo Edessa"/>
+        <a:font script="Syre" typeface="Estrangelo Edessa"/>
+        <a:font script="Sora" typeface="Nirmala UI"/>
+        <a:font script="Tale" typeface="Microsoft Tai Le"/>
+        <a:font script="Talu" typeface="Microsoft New Tai Lue"/>
+        <a:font script="Tfng" typeface="Ebrima"/>
+      </a:minorFont>
+    </a:fontScheme>
+    <a:fmtScheme name="Office">
+      <a:fillStyleLst>
+        <a:solidFill>
+          <a:schemeClr val="phClr"/>
+        </a:solidFill>
+        <a:gradFill rotWithShape="1">
+          <a:gsLst>
+            <a:gs pos="0">
+              <a:schemeClr val="phClr">
+                <a:lumMod val="110000"/>
+                <a:satMod val="105000"/>
+                <a:tint val="67000"/>
+              </a:schemeClr>
+            </a:gs>
+            <a:gs pos="50000">
+              <a:schemeClr val="phClr">
+                <a:lumMod val="105000"/>
+                <a:satMod val="103000"/>
+                <a:tint val="73000"/>
+              </a:schemeClr>
+            </a:gs>
+            <a:gs pos="100000">
+              <a:schemeClr val="phClr">
+                <a:lumMod val="105000"/>
+                <a:satMod val="109000"/>
+                <a:tint val="81000"/>
+              </a:schemeClr>
+            </a:gs>
+          </a:gsLst>
+          <a:lin ang="5400000" scaled="0"/>
+        </a:gradFill>
+        <a:gradFill rotWithShape="1">
+          <a:gsLst>
+            <a:gs pos="0">
+              <a:schemeClr val="phClr">
+                <a:satMod val="103000"/>
+                <a:lumMod val="102000"/>
+                <a:tint val="94000"/>
+              </a:schemeClr>
+            </a:gs>
+            <a:gs pos="50000">
+              <a:schemeClr val="phClr">
+                <a:satMod val="110000"/>
+                <a:lumMod val="100000"/>
+                <a:shade val="100000"/>
+              </a:schemeClr>
+            </a:gs>
+            <a:gs pos="100000">
+              <a:schemeClr val="phClr">
+                <a:lumMod val="99000"/>
+                <a:satMod val="120000"/>
+                <a:shade val="78000"/>
+              </a:schemeClr>
+            </a:gs>
+          </a:gsLst>
+          <a:lin ang="5400000" scaled="0"/>
+        </a:gradFill>
+      </a:fillStyleLst>
+      <a:lnStyleLst>
+        <a:ln w="6350" cap="flat" cmpd="sng" algn="ctr">
+          <a:solidFill>
+            <a:schemeClr val="phClr"/>
+          </a:solidFill>
+          <a:prstDash val="solid"/>
+          <a:miter lim="800000"/>
+        </a:ln>
+        <a:ln w="12700" cap="flat" cmpd="sng" algn="ctr">
+          <a:solidFill>
+            <a:schemeClr val="phClr"/>
+          </a:solidFill>
+          <a:prstDash val="solid"/>
+          <a:miter lim="800000"/>
+        </a:ln>
+        <a:ln w="19050" cap="flat" cmpd="sng" algn="ctr">
+          <a:solidFill>
+            <a:schemeClr val="phClr"/>
+          </a:solidFill>
+          <a:prstDash val="solid"/>
+          <a:miter lim="800000"/>
+        </a:ln>
+      </a:lnStyleLst>
+      <a:effectStyleLst>
+        <a:effectStyle>
+          <a:effectLst/>
+        </a:effectStyle>
+        <a:effectStyle>
+          <a:effectLst/>
+        </a:effectStyle>
+        <a:effectStyle>
+          <a:effectLst>
+            <a:outerShdw blurRad="57150" dist="19050" dir="5400000" algn="ctr" rotWithShape="0">
+              <a:srgbClr val="000000">
+                <a:alpha val="63000"/>
+              </a:srgbClr>
+            </a:outerShdw>
+          </a:effectLst>
+        </a:effectStyle>
+      </a:effectStyleLst>
+      <a:bgFillStyleLst>
+        <a:solidFill>
+          <a:schemeClr val="phClr"/>
+        </a:solidFill>
+        <a:solidFill>
+          <a:schemeClr val="phClr">
+            <a:tint val="95000"/>
+            <a:satMod val="170000"/>
+          </a:schemeClr>
+        </a:solidFill>
+        <a:gradFill rotWithShape="1">
+          <a:gsLst>
+            <a:gs pos="0">
+              <a:schemeClr val="phClr">
+                <a:tint val="93000"/>
+                <a:satMod val="150000"/>
+                <a:shade val="98000"/>
+                <a:lumMod val="102000"/>
+              </a:schemeClr>
+            </a:gs>
+            <a:gs pos="50000">
+              <a:schemeClr val="phClr">
+                <a:tint val="98000"/>
+                <a:satMod val="130000"/>
+                <a:shade val="90000"/>
+                <a:lumMod val="103000"/>
+              </a:schemeClr>
+            </a:gs>
+            <a:gs pos="100000">
+              <a:schemeClr val="phClr">
+                <a:shade val="63000"/>
+                <a:satMod val="120000"/>
+              </a:schemeClr>
+            </a:gs>
+          </a:gsLst>
+          <a:lin ang="5400000" scaled="0"/>
+        </a:gradFill>
+      </a:bgFillStyleLst>
+    </a:fmtScheme>
+  </a:themeElements>
+  <a:objectDefaults/>
+  <a:extraClrSchemeLst/>
+  <a:extLst>
+    <a:ext uri="{05A4C25C-085E-4340-85A3-A5531E510DB2}">
+      <thm15:themeFamily xmlns:thm15="http://schemas.microsoft.com/office/thememl/2012/main" name="Office Theme" id="{62F939B6-93AF-4DB8-9C6B-D6C7DFDC589F}" vid="{4A3C46E8-61CC-4603-A589-7422A47A8E4A}"/>
+    </a:ext>
+  </a:extLst>
+</a:theme>
 </file>
</xml_diff>